<commit_message>
docs(architecture): restyle pipeline diagram in layered system-boundary style
White background with a dashed system boundary and dotted sub-boxes
segregating Ingestion, Serving, Query Pipeline, Storage, and Tracing layers;
solid arrows for the primary data flow, dashed arrows for the Langfuse trace
path, matching the visual language of standard cloud architecture diagrams.
</commit_message>
<xml_diff>
--- a/docs/architecture-diagram.pptx
+++ b/docs/architecture-diagram.pptx
@@ -3103,7 +3103,7 @@
             <a:avLst/>
           </a:prstGeom>
           <a:solidFill>
-            <a:srgbClr val="0A0D0B"/>
+            <a:srgbClr val="FFFFFF"/>
           </a:solidFill>
           <a:ln>
             <a:noFill/>
@@ -3134,103 +3134,26 @@
       </p:sp>
       <p:sp>
         <p:nvSpPr>
-          <p:cNvPr id="3" name="TextBox 2"/>
-          <p:cNvSpPr txBox="1"/>
-          <p:nvPr/>
-        </p:nvSpPr>
-        <p:spPr>
-          <a:xfrm>
-            <a:off x="457200" y="292608"/>
-            <a:ext cx="11277295" cy="320040"/>
-          </a:xfrm>
-          <a:prstGeom prst="rect">
-            <a:avLst/>
-          </a:prstGeom>
-          <a:noFill/>
-        </p:spPr>
-        <p:txBody>
-          <a:bodyPr wrap="square" anchor="ctr" lIns="0" rIns="0" tIns="0" bIns="0">
-            <a:noAutofit/>
-          </a:bodyPr>
-          <a:lstStyle/>
-          <a:p>
-            <a:pPr algn="ctr">
-              <a:lnSpc>
-                <a:spcPct val="115000"/>
-              </a:lnSpc>
-            </a:pPr>
-            <a:r>
-              <a:rPr sz="1200" b="1">
-                <a:solidFill>
-                  <a:srgbClr val="6FE3A6"/>
-                </a:solidFill>
-                <a:latin typeface="Courier New"/>
-              </a:rPr>
-              <a:t>QUERY PIPELINE</a:t>
-            </a:r>
-          </a:p>
-        </p:txBody>
-      </p:sp>
-      <p:sp>
-        <p:nvSpPr>
-          <p:cNvPr id="4" name="TextBox 3"/>
-          <p:cNvSpPr txBox="1"/>
-          <p:nvPr/>
-        </p:nvSpPr>
-        <p:spPr>
-          <a:xfrm>
-            <a:off x="457200" y="566928"/>
-            <a:ext cx="11277295" cy="502920"/>
-          </a:xfrm>
-          <a:prstGeom prst="rect">
-            <a:avLst/>
-          </a:prstGeom>
-          <a:noFill/>
-        </p:spPr>
-        <p:txBody>
-          <a:bodyPr wrap="square" anchor="ctr" lIns="0" rIns="0" tIns="0" bIns="0">
-            <a:noAutofit/>
-          </a:bodyPr>
-          <a:lstStyle/>
-          <a:p>
-            <a:pPr algn="ctr">
-              <a:lnSpc>
-                <a:spcPct val="115000"/>
-              </a:lnSpc>
-            </a:pPr>
-            <a:r>
-              <a:rPr sz="2600" b="1">
-                <a:solidFill>
-                  <a:srgbClr val="EEF1EA"/>
-                </a:solidFill>
-                <a:latin typeface="Helvetica Neue"/>
-              </a:rPr>
-              <a:t>From an ERPNext record to a cited answer</a:t>
-            </a:r>
-          </a:p>
-        </p:txBody>
-      </p:sp>
-      <p:sp>
-        <p:nvSpPr>
-          <p:cNvPr id="5" name="Rounded Rectangle 4"/>
+          <p:cNvPr id="3" name="Rounded Rectangle 2"/>
           <p:cNvSpPr/>
           <p:nvPr/>
         </p:nvSpPr>
         <p:spPr>
           <a:xfrm>
-            <a:off x="502920" y="1737360"/>
-            <a:ext cx="914400" cy="914400"/>
+            <a:off x="1600200" y="502920"/>
+            <a:ext cx="10104120" cy="5349240"/>
           </a:xfrm>
           <a:prstGeom prst="roundRect">
             <a:avLst>
-              <a:gd name="adj" fmla="val 22000"/>
+              <a:gd name="adj" fmla="val 3000"/>
             </a:avLst>
           </a:prstGeom>
-          <a:solidFill>
-            <a:srgbClr val="F4F6F0"/>
-          </a:solidFill>
-          <a:ln>
-            <a:noFill/>
+          <a:noFill/>
+          <a:ln w="15875">
+            <a:solidFill>
+              <a:srgbClr val="9AA3AC"/>
+            </a:solidFill>
+            <a:prstDash val="dash"/>
           </a:ln>
           <a:effectLst/>
         </p:spPr>
@@ -3258,7 +3181,7 @@
       </p:sp>
       <p:pic>
         <p:nvPicPr>
-          <p:cNvPr id="6" name="Picture 5" descr="erpnext.svg.png"/>
+          <p:cNvPr id="4" name="Picture 3" descr="erpnext.svg.png"/>
           <p:cNvPicPr>
             <a:picLocks noChangeAspect="1"/>
           </p:cNvPicPr>
@@ -3272,8 +3195,8 @@
         </p:blipFill>
         <p:spPr>
           <a:xfrm>
-            <a:off x="704088" y="1938528"/>
-            <a:ext cx="512064" cy="512064"/>
+            <a:off x="493776" y="768095"/>
+            <a:ext cx="566928" cy="566928"/>
           </a:xfrm>
           <a:prstGeom prst="rect">
             <a:avLst/>
@@ -3282,14 +3205,14 @@
       </p:pic>
       <p:sp>
         <p:nvSpPr>
-          <p:cNvPr id="7" name="TextBox 6"/>
+          <p:cNvPr id="5" name="TextBox 4"/>
           <p:cNvSpPr txBox="1"/>
           <p:nvPr/>
         </p:nvSpPr>
         <p:spPr>
           <a:xfrm>
-            <a:off x="274320" y="2761488"/>
-            <a:ext cx="1371600" cy="274320"/>
+            <a:off x="137160" y="1417320"/>
+            <a:ext cx="1280160" cy="228600"/>
           </a:xfrm>
           <a:prstGeom prst="rect">
             <a:avLst/>
@@ -3304,13 +3227,13 @@
           <a:p>
             <a:pPr algn="ctr">
               <a:lnSpc>
-                <a:spcPct val="115000"/>
+                <a:spcPct val="110000"/>
               </a:lnSpc>
             </a:pPr>
             <a:r>
-              <a:rPr sz="1350" b="1">
+              <a:rPr sz="1150" b="1" i="0">
                 <a:solidFill>
-                  <a:srgbClr val="EEF1EA"/>
+                  <a:srgbClr val="24272B"/>
                 </a:solidFill>
                 <a:latin typeface="Helvetica Neue"/>
               </a:rPr>
@@ -3321,14 +3244,14 @@
       </p:sp>
       <p:sp>
         <p:nvSpPr>
-          <p:cNvPr id="8" name="TextBox 7"/>
+          <p:cNvPr id="6" name="TextBox 5"/>
           <p:cNvSpPr txBox="1"/>
           <p:nvPr/>
         </p:nvSpPr>
         <p:spPr>
           <a:xfrm>
-            <a:off x="274320" y="3035808"/>
-            <a:ext cx="1371600" cy="320040"/>
+            <a:off x="137160" y="1645920"/>
+            <a:ext cx="1280160" cy="365760"/>
           </a:xfrm>
           <a:prstGeom prst="rect">
             <a:avLst/>
@@ -3343,44 +3266,176 @@
           <a:p>
             <a:pPr algn="ctr">
               <a:lnSpc>
-                <a:spcPct val="115000"/>
+                <a:spcPct val="120000"/>
               </a:lnSpc>
             </a:pPr>
             <a:r>
-              <a:rPr sz="950" b="0">
+              <a:rPr sz="800" b="0" i="0">
                 <a:solidFill>
-                  <a:srgbClr val="9FA99C"/>
+                  <a:srgbClr val="6B727A"/>
                 </a:solidFill>
                 <a:latin typeface="Courier New"/>
               </a:rPr>
-              <a:t>source data</a:t>
-            </a:r>
-          </a:p>
-        </p:txBody>
-      </p:sp>
-      <p:sp>
-        <p:nvSpPr>
-          <p:cNvPr id="9" name="Rounded Rectangle 8"/>
+              <a:t>source ERP data</a:t>
+            </a:r>
+          </a:p>
+          <a:p>
+            <a:pPr algn="ctr">
+              <a:lnSpc>
+                <a:spcPct val="120000"/>
+              </a:lnSpc>
+            </a:pPr>
+            <a:r>
+              <a:rPr sz="800" b="0" i="0">
+                <a:solidFill>
+                  <a:srgbClr val="6B727A"/>
+                </a:solidFill>
+                <a:latin typeface="Courier New"/>
+              </a:rPr>
+              <a:t>(Frappe REST)</a:t>
+            </a:r>
+          </a:p>
+        </p:txBody>
+      </p:sp>
+      <p:sp>
+        <p:nvSpPr>
+          <p:cNvPr id="7" name="TextBox 6"/>
+          <p:cNvSpPr txBox="1"/>
+          <p:nvPr/>
+        </p:nvSpPr>
+        <p:spPr>
+          <a:xfrm>
+            <a:off x="493776" y="4425696"/>
+            <a:ext cx="566928" cy="566928"/>
+          </a:xfrm>
+          <a:prstGeom prst="rect">
+            <a:avLst/>
+          </a:prstGeom>
+          <a:noFill/>
+        </p:spPr>
+        <p:txBody>
+          <a:bodyPr wrap="square" anchor="ctr" lIns="0" rIns="0" tIns="0" bIns="0">
+            <a:noAutofit/>
+          </a:bodyPr>
+          <a:lstStyle/>
+          <a:p>
+            <a:pPr algn="ctr">
+              <a:lnSpc>
+                <a:spcPct val="110000"/>
+              </a:lnSpc>
+            </a:pPr>
+            <a:r>
+              <a:rPr sz="2600" b="0" i="0">
+                <a:solidFill>
+                  <a:srgbClr val="24272B"/>
+                </a:solidFill>
+                <a:latin typeface="Helvetica Neue"/>
+              </a:rPr>
+              <a:t>🧑‍💼</a:t>
+            </a:r>
+          </a:p>
+        </p:txBody>
+      </p:sp>
+      <p:sp>
+        <p:nvSpPr>
+          <p:cNvPr id="8" name="TextBox 7"/>
+          <p:cNvSpPr txBox="1"/>
+          <p:nvPr/>
+        </p:nvSpPr>
+        <p:spPr>
+          <a:xfrm>
+            <a:off x="45720" y="5074920"/>
+            <a:ext cx="1463040" cy="228600"/>
+          </a:xfrm>
+          <a:prstGeom prst="rect">
+            <a:avLst/>
+          </a:prstGeom>
+          <a:noFill/>
+        </p:spPr>
+        <p:txBody>
+          <a:bodyPr wrap="square" anchor="ctr" lIns="0" rIns="0" tIns="0" bIns="0">
+            <a:noAutofit/>
+          </a:bodyPr>
+          <a:lstStyle/>
+          <a:p>
+            <a:pPr algn="ctr">
+              <a:lnSpc>
+                <a:spcPct val="110000"/>
+              </a:lnSpc>
+            </a:pPr>
+            <a:r>
+              <a:rPr sz="1150" b="1" i="0">
+                <a:solidFill>
+                  <a:srgbClr val="24272B"/>
+                </a:solidFill>
+                <a:latin typeface="Helvetica Neue"/>
+              </a:rPr>
+              <a:t>Procurement team</a:t>
+            </a:r>
+          </a:p>
+        </p:txBody>
+      </p:sp>
+      <p:sp>
+        <p:nvSpPr>
+          <p:cNvPr id="9" name="TextBox 8"/>
+          <p:cNvSpPr txBox="1"/>
+          <p:nvPr/>
+        </p:nvSpPr>
+        <p:spPr>
+          <a:xfrm>
+            <a:off x="137160" y="5303520"/>
+            <a:ext cx="1280160" cy="274320"/>
+          </a:xfrm>
+          <a:prstGeom prst="rect">
+            <a:avLst/>
+          </a:prstGeom>
+          <a:noFill/>
+        </p:spPr>
+        <p:txBody>
+          <a:bodyPr wrap="square" anchor="ctr" lIns="0" rIns="0" tIns="0" bIns="0">
+            <a:noAutofit/>
+          </a:bodyPr>
+          <a:lstStyle/>
+          <a:p>
+            <a:pPr algn="ctr">
+              <a:lnSpc>
+                <a:spcPct val="110000"/>
+              </a:lnSpc>
+            </a:pPr>
+            <a:r>
+              <a:rPr sz="800" b="0" i="0">
+                <a:solidFill>
+                  <a:srgbClr val="6B727A"/>
+                </a:solidFill>
+                <a:latin typeface="Courier New"/>
+              </a:rPr>
+              <a:t>chat query</a:t>
+            </a:r>
+          </a:p>
+        </p:txBody>
+      </p:sp>
+      <p:sp>
+        <p:nvSpPr>
+          <p:cNvPr id="10" name="Rounded Rectangle 9"/>
           <p:cNvSpPr/>
           <p:nvPr/>
         </p:nvSpPr>
         <p:spPr>
           <a:xfrm>
-            <a:off x="1874519" y="1600200"/>
-            <a:ext cx="1600200" cy="1600200"/>
+            <a:off x="4160520" y="822960"/>
+            <a:ext cx="3246120" cy="1691640"/>
           </a:xfrm>
           <a:prstGeom prst="roundRect">
             <a:avLst>
-              <a:gd name="adj" fmla="val 10000"/>
+              <a:gd name="adj" fmla="val 6000"/>
             </a:avLst>
           </a:prstGeom>
-          <a:solidFill>
-            <a:srgbClr val="121613"/>
-          </a:solidFill>
+          <a:noFill/>
           <a:ln w="12700">
             <a:solidFill>
-              <a:srgbClr val="2B3830"/>
+              <a:srgbClr val="444B53"/>
             </a:solidFill>
+            <a:prstDash val="sysDot"/>
           </a:ln>
           <a:effectLst/>
         </p:spPr>
@@ -3408,14 +3463,14 @@
       </p:sp>
       <p:sp>
         <p:nvSpPr>
-          <p:cNvPr id="10" name="TextBox 9"/>
+          <p:cNvPr id="11" name="TextBox 10"/>
           <p:cNvSpPr txBox="1"/>
           <p:nvPr/>
         </p:nvSpPr>
         <p:spPr>
           <a:xfrm>
-            <a:off x="1965960" y="2039112"/>
-            <a:ext cx="1417320" cy="274320"/>
+            <a:off x="4297680" y="896112"/>
+            <a:ext cx="2971800" cy="201168"/>
           </a:xfrm>
           <a:prstGeom prst="rect">
             <a:avLst/>
@@ -3428,80 +3483,39 @@
           </a:bodyPr>
           <a:lstStyle/>
           <a:p>
-            <a:pPr algn="ctr">
+            <a:pPr algn="l">
               <a:lnSpc>
-                <a:spcPct val="115000"/>
+                <a:spcPct val="110000"/>
               </a:lnSpc>
             </a:pPr>
             <a:r>
-              <a:rPr sz="1500" b="1">
+              <a:rPr sz="950" b="1" i="0">
                 <a:solidFill>
-                  <a:srgbClr val="EEF1EA"/>
-                </a:solidFill>
-                <a:latin typeface="Helvetica Neue"/>
-              </a:rPr>
-              <a:t>Ingestion</a:t>
-            </a:r>
-          </a:p>
-        </p:txBody>
-      </p:sp>
-      <p:sp>
-        <p:nvSpPr>
-          <p:cNvPr id="11" name="TextBox 10"/>
-          <p:cNvSpPr txBox="1"/>
-          <p:nvPr/>
-        </p:nvSpPr>
-        <p:spPr>
-          <a:xfrm>
-            <a:off x="1984248" y="2368296"/>
-            <a:ext cx="1380744" cy="548640"/>
-          </a:xfrm>
-          <a:prstGeom prst="rect">
-            <a:avLst/>
-          </a:prstGeom>
-          <a:noFill/>
-        </p:spPr>
-        <p:txBody>
-          <a:bodyPr wrap="square" anchor="ctr" lIns="0" rIns="0" tIns="0" bIns="0">
-            <a:noAutofit/>
-          </a:bodyPr>
-          <a:lstStyle/>
-          <a:p>
-            <a:pPr algn="ctr">
-              <a:lnSpc>
-                <a:spcPct val="130000"/>
-              </a:lnSpc>
-            </a:pPr>
-            <a:r>
-              <a:rPr sz="950" b="0">
-                <a:solidFill>
-                  <a:srgbClr val="9FA99C"/>
+                  <a:srgbClr val="2B6C53"/>
                 </a:solidFill>
                 <a:latin typeface="Courier New"/>
               </a:rPr>
-              <a:t>parse  ·  chunk  ·  embed</a:t>
-            </a:r>
-          </a:p>
-        </p:txBody>
-      </p:sp>
-      <p:sp>
-        <p:nvSpPr>
-          <p:cNvPr id="12" name="Rounded Rectangle 11"/>
+              <a:t>INGESTION</a:t>
+            </a:r>
+          </a:p>
+        </p:txBody>
+      </p:sp>
+      <p:sp>
+        <p:nvSpPr>
+          <p:cNvPr id="12" name="Oval 11"/>
           <p:cNvSpPr/>
           <p:nvPr/>
         </p:nvSpPr>
         <p:spPr>
           <a:xfrm>
-            <a:off x="3931920" y="1737360"/>
-            <a:ext cx="914400" cy="914400"/>
-          </a:xfrm>
-          <a:prstGeom prst="roundRect">
-            <a:avLst>
-              <a:gd name="adj" fmla="val 22000"/>
-            </a:avLst>
+            <a:off x="4457700" y="1271016"/>
+            <a:ext cx="457200" cy="457200"/>
+          </a:xfrm>
+          <a:prstGeom prst="ellipse">
+            <a:avLst/>
           </a:prstGeom>
           <a:solidFill>
-            <a:srgbClr val="F4F6F0"/>
+            <a:srgbClr val="EEF1F4"/>
           </a:solidFill>
           <a:ln>
             <a:noFill/>
@@ -3530,9 +3544,702 @@
           </a:p>
         </p:txBody>
       </p:sp>
+      <p:sp>
+        <p:nvSpPr>
+          <p:cNvPr id="13" name="TextBox 12"/>
+          <p:cNvSpPr txBox="1"/>
+          <p:nvPr/>
+        </p:nvSpPr>
+        <p:spPr>
+          <a:xfrm>
+            <a:off x="4457700" y="1271016"/>
+            <a:ext cx="457200" cy="457200"/>
+          </a:xfrm>
+          <a:prstGeom prst="rect">
+            <a:avLst/>
+          </a:prstGeom>
+          <a:noFill/>
+        </p:spPr>
+        <p:txBody>
+          <a:bodyPr wrap="square" anchor="ctr" lIns="0" rIns="0" tIns="0" bIns="0">
+            <a:noAutofit/>
+          </a:bodyPr>
+          <a:lstStyle/>
+          <a:p>
+            <a:pPr algn="ctr">
+              <a:lnSpc>
+                <a:spcPct val="110000"/>
+              </a:lnSpc>
+            </a:pPr>
+            <a:r>
+              <a:rPr sz="2000" b="0" i="0">
+                <a:solidFill>
+                  <a:srgbClr val="24272B"/>
+                </a:solidFill>
+                <a:latin typeface="Helvetica Neue"/>
+              </a:rPr>
+              <a:t>📄</a:t>
+            </a:r>
+          </a:p>
+        </p:txBody>
+      </p:sp>
+      <p:sp>
+        <p:nvSpPr>
+          <p:cNvPr id="14" name="TextBox 13"/>
+          <p:cNvSpPr txBox="1"/>
+          <p:nvPr/>
+        </p:nvSpPr>
+        <p:spPr>
+          <a:xfrm>
+            <a:off x="4297680" y="1773936"/>
+            <a:ext cx="777240" cy="201168"/>
+          </a:xfrm>
+          <a:prstGeom prst="rect">
+            <a:avLst/>
+          </a:prstGeom>
+          <a:noFill/>
+        </p:spPr>
+        <p:txBody>
+          <a:bodyPr wrap="square" anchor="ctr" lIns="0" rIns="0" tIns="0" bIns="0">
+            <a:noAutofit/>
+          </a:bodyPr>
+          <a:lstStyle/>
+          <a:p>
+            <a:pPr algn="ctr">
+              <a:lnSpc>
+                <a:spcPct val="110000"/>
+              </a:lnSpc>
+            </a:pPr>
+            <a:r>
+              <a:rPr sz="850" b="1" i="0">
+                <a:solidFill>
+                  <a:srgbClr val="24272B"/>
+                </a:solidFill>
+                <a:latin typeface="Helvetica Neue"/>
+              </a:rPr>
+              <a:t>Parse</a:t>
+            </a:r>
+          </a:p>
+        </p:txBody>
+      </p:sp>
+      <p:cxnSp>
+        <p:nvCxnSpPr>
+          <p:cNvPr id="15" name="Connector 14"/>
+          <p:cNvCxnSpPr/>
+          <p:nvPr/>
+        </p:nvCxnSpPr>
+        <p:spPr>
+          <a:xfrm>
+            <a:off x="4960620" y="1499616"/>
+            <a:ext cx="548639" cy="0"/>
+          </a:xfrm>
+          <a:prstGeom prst="line">
+            <a:avLst/>
+          </a:prstGeom>
+          <a:ln w="12700">
+            <a:solidFill>
+              <a:srgbClr val="444B53"/>
+            </a:solidFill>
+            <a:tailEnd type="triangle" w="med" len="med"/>
+          </a:ln>
+          <a:effectLst/>
+        </p:spPr>
+        <p:style>
+          <a:lnRef idx="2">
+            <a:schemeClr val="accent1"/>
+          </a:lnRef>
+          <a:fillRef idx="0">
+            <a:schemeClr val="accent1"/>
+          </a:fillRef>
+          <a:effectRef idx="1">
+            <a:schemeClr val="accent1"/>
+          </a:effectRef>
+          <a:fontRef idx="minor">
+            <a:schemeClr val="tx1"/>
+          </a:fontRef>
+        </p:style>
+      </p:cxnSp>
+      <p:sp>
+        <p:nvSpPr>
+          <p:cNvPr id="16" name="Oval 15"/>
+          <p:cNvSpPr/>
+          <p:nvPr/>
+        </p:nvSpPr>
+        <p:spPr>
+          <a:xfrm>
+            <a:off x="5554980" y="1271016"/>
+            <a:ext cx="457200" cy="457200"/>
+          </a:xfrm>
+          <a:prstGeom prst="ellipse">
+            <a:avLst/>
+          </a:prstGeom>
+          <a:solidFill>
+            <a:srgbClr val="EEF1F4"/>
+          </a:solidFill>
+          <a:ln>
+            <a:noFill/>
+          </a:ln>
+          <a:effectLst/>
+        </p:spPr>
+        <p:style>
+          <a:lnRef idx="1">
+            <a:schemeClr val="accent1"/>
+          </a:lnRef>
+          <a:fillRef idx="3">
+            <a:schemeClr val="accent1"/>
+          </a:fillRef>
+          <a:effectRef idx="2">
+            <a:schemeClr val="accent1"/>
+          </a:effectRef>
+          <a:fontRef idx="minor">
+            <a:schemeClr val="lt1"/>
+          </a:fontRef>
+        </p:style>
+        <p:txBody>
+          <a:bodyPr rtlCol="0" anchor="ctr"/>
+          <a:lstStyle/>
+          <a:p>
+            <a:pPr algn="ctr"/>
+          </a:p>
+        </p:txBody>
+      </p:sp>
+      <p:sp>
+        <p:nvSpPr>
+          <p:cNvPr id="17" name="TextBox 16"/>
+          <p:cNvSpPr txBox="1"/>
+          <p:nvPr/>
+        </p:nvSpPr>
+        <p:spPr>
+          <a:xfrm>
+            <a:off x="5554980" y="1271016"/>
+            <a:ext cx="457200" cy="457200"/>
+          </a:xfrm>
+          <a:prstGeom prst="rect">
+            <a:avLst/>
+          </a:prstGeom>
+          <a:noFill/>
+        </p:spPr>
+        <p:txBody>
+          <a:bodyPr wrap="square" anchor="ctr" lIns="0" rIns="0" tIns="0" bIns="0">
+            <a:noAutofit/>
+          </a:bodyPr>
+          <a:lstStyle/>
+          <a:p>
+            <a:pPr algn="ctr">
+              <a:lnSpc>
+                <a:spcPct val="110000"/>
+              </a:lnSpc>
+            </a:pPr>
+            <a:r>
+              <a:rPr sz="2000" b="0" i="0">
+                <a:solidFill>
+                  <a:srgbClr val="24272B"/>
+                </a:solidFill>
+                <a:latin typeface="Helvetica Neue"/>
+              </a:rPr>
+              <a:t>✂️</a:t>
+            </a:r>
+          </a:p>
+        </p:txBody>
+      </p:sp>
+      <p:sp>
+        <p:nvSpPr>
+          <p:cNvPr id="18" name="TextBox 17"/>
+          <p:cNvSpPr txBox="1"/>
+          <p:nvPr/>
+        </p:nvSpPr>
+        <p:spPr>
+          <a:xfrm>
+            <a:off x="5394960" y="1773936"/>
+            <a:ext cx="777240" cy="201168"/>
+          </a:xfrm>
+          <a:prstGeom prst="rect">
+            <a:avLst/>
+          </a:prstGeom>
+          <a:noFill/>
+        </p:spPr>
+        <p:txBody>
+          <a:bodyPr wrap="square" anchor="ctr" lIns="0" rIns="0" tIns="0" bIns="0">
+            <a:noAutofit/>
+          </a:bodyPr>
+          <a:lstStyle/>
+          <a:p>
+            <a:pPr algn="ctr">
+              <a:lnSpc>
+                <a:spcPct val="110000"/>
+              </a:lnSpc>
+            </a:pPr>
+            <a:r>
+              <a:rPr sz="850" b="1" i="0">
+                <a:solidFill>
+                  <a:srgbClr val="24272B"/>
+                </a:solidFill>
+                <a:latin typeface="Helvetica Neue"/>
+              </a:rPr>
+              <a:t>Chunk</a:t>
+            </a:r>
+          </a:p>
+        </p:txBody>
+      </p:sp>
+      <p:cxnSp>
+        <p:nvCxnSpPr>
+          <p:cNvPr id="19" name="Connector 18"/>
+          <p:cNvCxnSpPr/>
+          <p:nvPr/>
+        </p:nvCxnSpPr>
+        <p:spPr>
+          <a:xfrm>
+            <a:off x="6057900" y="1499616"/>
+            <a:ext cx="548640" cy="0"/>
+          </a:xfrm>
+          <a:prstGeom prst="line">
+            <a:avLst/>
+          </a:prstGeom>
+          <a:ln w="12700">
+            <a:solidFill>
+              <a:srgbClr val="444B53"/>
+            </a:solidFill>
+            <a:tailEnd type="triangle" w="med" len="med"/>
+          </a:ln>
+          <a:effectLst/>
+        </p:spPr>
+        <p:style>
+          <a:lnRef idx="2">
+            <a:schemeClr val="accent1"/>
+          </a:lnRef>
+          <a:fillRef idx="0">
+            <a:schemeClr val="accent1"/>
+          </a:fillRef>
+          <a:effectRef idx="1">
+            <a:schemeClr val="accent1"/>
+          </a:effectRef>
+          <a:fontRef idx="minor">
+            <a:schemeClr val="tx1"/>
+          </a:fontRef>
+        </p:style>
+      </p:cxnSp>
+      <p:sp>
+        <p:nvSpPr>
+          <p:cNvPr id="20" name="Oval 19"/>
+          <p:cNvSpPr/>
+          <p:nvPr/>
+        </p:nvSpPr>
+        <p:spPr>
+          <a:xfrm>
+            <a:off x="6652260" y="1271016"/>
+            <a:ext cx="457200" cy="457200"/>
+          </a:xfrm>
+          <a:prstGeom prst="ellipse">
+            <a:avLst/>
+          </a:prstGeom>
+          <a:solidFill>
+            <a:srgbClr val="EEF1F4"/>
+          </a:solidFill>
+          <a:ln>
+            <a:noFill/>
+          </a:ln>
+          <a:effectLst/>
+        </p:spPr>
+        <p:style>
+          <a:lnRef idx="1">
+            <a:schemeClr val="accent1"/>
+          </a:lnRef>
+          <a:fillRef idx="3">
+            <a:schemeClr val="accent1"/>
+          </a:fillRef>
+          <a:effectRef idx="2">
+            <a:schemeClr val="accent1"/>
+          </a:effectRef>
+          <a:fontRef idx="minor">
+            <a:schemeClr val="lt1"/>
+          </a:fontRef>
+        </p:style>
+        <p:txBody>
+          <a:bodyPr rtlCol="0" anchor="ctr"/>
+          <a:lstStyle/>
+          <a:p>
+            <a:pPr algn="ctr"/>
+          </a:p>
+        </p:txBody>
+      </p:sp>
+      <p:sp>
+        <p:nvSpPr>
+          <p:cNvPr id="21" name="TextBox 20"/>
+          <p:cNvSpPr txBox="1"/>
+          <p:nvPr/>
+        </p:nvSpPr>
+        <p:spPr>
+          <a:xfrm>
+            <a:off x="6652260" y="1271016"/>
+            <a:ext cx="457200" cy="457200"/>
+          </a:xfrm>
+          <a:prstGeom prst="rect">
+            <a:avLst/>
+          </a:prstGeom>
+          <a:noFill/>
+        </p:spPr>
+        <p:txBody>
+          <a:bodyPr wrap="square" anchor="ctr" lIns="0" rIns="0" tIns="0" bIns="0">
+            <a:noAutofit/>
+          </a:bodyPr>
+          <a:lstStyle/>
+          <a:p>
+            <a:pPr algn="ctr">
+              <a:lnSpc>
+                <a:spcPct val="110000"/>
+              </a:lnSpc>
+            </a:pPr>
+            <a:r>
+              <a:rPr sz="2000" b="0" i="0">
+                <a:solidFill>
+                  <a:srgbClr val="24272B"/>
+                </a:solidFill>
+                <a:latin typeface="Helvetica Neue"/>
+              </a:rPr>
+              <a:t>🔢</a:t>
+            </a:r>
+          </a:p>
+        </p:txBody>
+      </p:sp>
+      <p:sp>
+        <p:nvSpPr>
+          <p:cNvPr id="22" name="TextBox 21"/>
+          <p:cNvSpPr txBox="1"/>
+          <p:nvPr/>
+        </p:nvSpPr>
+        <p:spPr>
+          <a:xfrm>
+            <a:off x="6492240" y="1773936"/>
+            <a:ext cx="777240" cy="201168"/>
+          </a:xfrm>
+          <a:prstGeom prst="rect">
+            <a:avLst/>
+          </a:prstGeom>
+          <a:noFill/>
+        </p:spPr>
+        <p:txBody>
+          <a:bodyPr wrap="square" anchor="ctr" lIns="0" rIns="0" tIns="0" bIns="0">
+            <a:noAutofit/>
+          </a:bodyPr>
+          <a:lstStyle/>
+          <a:p>
+            <a:pPr algn="ctr">
+              <a:lnSpc>
+                <a:spcPct val="110000"/>
+              </a:lnSpc>
+            </a:pPr>
+            <a:r>
+              <a:rPr sz="850" b="1" i="0">
+                <a:solidFill>
+                  <a:srgbClr val="24272B"/>
+                </a:solidFill>
+                <a:latin typeface="Helvetica Neue"/>
+              </a:rPr>
+              <a:t>Embed</a:t>
+            </a:r>
+          </a:p>
+        </p:txBody>
+      </p:sp>
+      <p:sp>
+        <p:nvSpPr>
+          <p:cNvPr id="23" name="Rounded Rectangle 22"/>
+          <p:cNvSpPr/>
+          <p:nvPr/>
+        </p:nvSpPr>
+        <p:spPr>
+          <a:xfrm>
+            <a:off x="4297680" y="2130552"/>
+            <a:ext cx="1431036" cy="292608"/>
+          </a:xfrm>
+          <a:prstGeom prst="roundRect">
+            <a:avLst>
+              <a:gd name="adj" fmla="val 50000"/>
+            </a:avLst>
+          </a:prstGeom>
+          <a:solidFill>
+            <a:srgbClr val="EEF1F4"/>
+          </a:solidFill>
+          <a:ln w="9525">
+            <a:solidFill>
+              <a:srgbClr val="C6CED6"/>
+            </a:solidFill>
+          </a:ln>
+          <a:effectLst/>
+        </p:spPr>
+        <p:style>
+          <a:lnRef idx="1">
+            <a:schemeClr val="accent1"/>
+          </a:lnRef>
+          <a:fillRef idx="3">
+            <a:schemeClr val="accent1"/>
+          </a:fillRef>
+          <a:effectRef idx="2">
+            <a:schemeClr val="accent1"/>
+          </a:effectRef>
+          <a:fontRef idx="minor">
+            <a:schemeClr val="lt1"/>
+          </a:fontRef>
+        </p:style>
+        <p:txBody>
+          <a:bodyPr rtlCol="0" anchor="ctr"/>
+          <a:lstStyle/>
+          <a:p>
+            <a:pPr algn="ctr"/>
+          </a:p>
+        </p:txBody>
+      </p:sp>
+      <p:sp>
+        <p:nvSpPr>
+          <p:cNvPr id="24" name="TextBox 23"/>
+          <p:cNvSpPr txBox="1"/>
+          <p:nvPr/>
+        </p:nvSpPr>
+        <p:spPr>
+          <a:xfrm>
+            <a:off x="4297680" y="2130552"/>
+            <a:ext cx="1431036" cy="292608"/>
+          </a:xfrm>
+          <a:prstGeom prst="rect">
+            <a:avLst/>
+          </a:prstGeom>
+          <a:noFill/>
+        </p:spPr>
+        <p:txBody>
+          <a:bodyPr wrap="square" anchor="ctr" lIns="0" rIns="0" tIns="0" bIns="0">
+            <a:noAutofit/>
+          </a:bodyPr>
+          <a:lstStyle/>
+          <a:p>
+            <a:pPr algn="ctr">
+              <a:lnSpc>
+                <a:spcPct val="110000"/>
+              </a:lnSpc>
+            </a:pPr>
+            <a:r>
+              <a:rPr sz="750" b="0" i="0">
+                <a:solidFill>
+                  <a:srgbClr val="6B727A"/>
+                </a:solidFill>
+                <a:latin typeface="Courier New"/>
+              </a:rPr>
+              <a:t>Structured → 1 vector</a:t>
+            </a:r>
+          </a:p>
+        </p:txBody>
+      </p:sp>
+      <p:sp>
+        <p:nvSpPr>
+          <p:cNvPr id="25" name="Rounded Rectangle 24"/>
+          <p:cNvSpPr/>
+          <p:nvPr/>
+        </p:nvSpPr>
+        <p:spPr>
+          <a:xfrm>
+            <a:off x="5838444" y="2130552"/>
+            <a:ext cx="1431036" cy="292608"/>
+          </a:xfrm>
+          <a:prstGeom prst="roundRect">
+            <a:avLst>
+              <a:gd name="adj" fmla="val 50000"/>
+            </a:avLst>
+          </a:prstGeom>
+          <a:solidFill>
+            <a:srgbClr val="EEF1F4"/>
+          </a:solidFill>
+          <a:ln w="9525">
+            <a:solidFill>
+              <a:srgbClr val="C6CED6"/>
+            </a:solidFill>
+          </a:ln>
+          <a:effectLst/>
+        </p:spPr>
+        <p:style>
+          <a:lnRef idx="1">
+            <a:schemeClr val="accent1"/>
+          </a:lnRef>
+          <a:fillRef idx="3">
+            <a:schemeClr val="accent1"/>
+          </a:fillRef>
+          <a:effectRef idx="2">
+            <a:schemeClr val="accent1"/>
+          </a:effectRef>
+          <a:fontRef idx="minor">
+            <a:schemeClr val="lt1"/>
+          </a:fontRef>
+        </p:style>
+        <p:txBody>
+          <a:bodyPr rtlCol="0" anchor="ctr"/>
+          <a:lstStyle/>
+          <a:p>
+            <a:pPr algn="ctr"/>
+          </a:p>
+        </p:txBody>
+      </p:sp>
+      <p:sp>
+        <p:nvSpPr>
+          <p:cNvPr id="26" name="TextBox 25"/>
+          <p:cNvSpPr txBox="1"/>
+          <p:nvPr/>
+        </p:nvSpPr>
+        <p:spPr>
+          <a:xfrm>
+            <a:off x="5838444" y="2130552"/>
+            <a:ext cx="1431036" cy="292608"/>
+          </a:xfrm>
+          <a:prstGeom prst="rect">
+            <a:avLst/>
+          </a:prstGeom>
+          <a:noFill/>
+        </p:spPr>
+        <p:txBody>
+          <a:bodyPr wrap="square" anchor="ctr" lIns="0" rIns="0" tIns="0" bIns="0">
+            <a:noAutofit/>
+          </a:bodyPr>
+          <a:lstStyle/>
+          <a:p>
+            <a:pPr algn="ctr">
+              <a:lnSpc>
+                <a:spcPct val="110000"/>
+              </a:lnSpc>
+            </a:pPr>
+            <a:r>
+              <a:rPr sz="750" b="0" i="0">
+                <a:solidFill>
+                  <a:srgbClr val="6B727A"/>
+                </a:solidFill>
+                <a:latin typeface="Courier New"/>
+              </a:rPr>
+              <a:t>Unstructured → chunks</a:t>
+            </a:r>
+          </a:p>
+        </p:txBody>
+      </p:sp>
+      <p:cxnSp>
+        <p:nvCxnSpPr>
+          <p:cNvPr id="27" name="Connector 26"/>
+          <p:cNvCxnSpPr/>
+          <p:nvPr/>
+        </p:nvCxnSpPr>
+        <p:spPr>
+          <a:xfrm>
+            <a:off x="1060704" y="1051560"/>
+            <a:ext cx="3099816" cy="617220"/>
+          </a:xfrm>
+          <a:prstGeom prst="bentConnector3">
+            <a:avLst/>
+          </a:prstGeom>
+          <a:ln w="19050">
+            <a:solidFill>
+              <a:srgbClr val="1A1D21"/>
+            </a:solidFill>
+            <a:tailEnd type="triangle" w="med" len="med"/>
+          </a:ln>
+          <a:effectLst/>
+        </p:spPr>
+        <p:style>
+          <a:lnRef idx="2">
+            <a:schemeClr val="accent1"/>
+          </a:lnRef>
+          <a:fillRef idx="0">
+            <a:schemeClr val="accent1"/>
+          </a:fillRef>
+          <a:effectRef idx="1">
+            <a:schemeClr val="accent1"/>
+          </a:effectRef>
+          <a:fontRef idx="minor">
+            <a:schemeClr val="tx1"/>
+          </a:fontRef>
+        </p:style>
+      </p:cxnSp>
+      <p:sp>
+        <p:nvSpPr>
+          <p:cNvPr id="28" name="Rounded Rectangle 27"/>
+          <p:cNvSpPr/>
+          <p:nvPr/>
+        </p:nvSpPr>
+        <p:spPr>
+          <a:xfrm>
+            <a:off x="1874519" y="3246120"/>
+            <a:ext cx="1965960" cy="2331720"/>
+          </a:xfrm>
+          <a:prstGeom prst="roundRect">
+            <a:avLst>
+              <a:gd name="adj" fmla="val 6000"/>
+            </a:avLst>
+          </a:prstGeom>
+          <a:noFill/>
+          <a:ln w="12700">
+            <a:solidFill>
+              <a:srgbClr val="444B53"/>
+            </a:solidFill>
+            <a:prstDash val="sysDot"/>
+          </a:ln>
+          <a:effectLst/>
+        </p:spPr>
+        <p:style>
+          <a:lnRef idx="1">
+            <a:schemeClr val="accent1"/>
+          </a:lnRef>
+          <a:fillRef idx="3">
+            <a:schemeClr val="accent1"/>
+          </a:fillRef>
+          <a:effectRef idx="2">
+            <a:schemeClr val="accent1"/>
+          </a:effectRef>
+          <a:fontRef idx="minor">
+            <a:schemeClr val="lt1"/>
+          </a:fontRef>
+        </p:style>
+        <p:txBody>
+          <a:bodyPr rtlCol="0" anchor="ctr"/>
+          <a:lstStyle/>
+          <a:p>
+            <a:pPr algn="ctr"/>
+          </a:p>
+        </p:txBody>
+      </p:sp>
+      <p:sp>
+        <p:nvSpPr>
+          <p:cNvPr id="29" name="TextBox 28"/>
+          <p:cNvSpPr txBox="1"/>
+          <p:nvPr/>
+        </p:nvSpPr>
+        <p:spPr>
+          <a:xfrm>
+            <a:off x="1984248" y="3319272"/>
+            <a:ext cx="1746504" cy="201168"/>
+          </a:xfrm>
+          <a:prstGeom prst="rect">
+            <a:avLst/>
+          </a:prstGeom>
+          <a:noFill/>
+        </p:spPr>
+        <p:txBody>
+          <a:bodyPr wrap="square" anchor="ctr" lIns="0" rIns="0" tIns="0" bIns="0">
+            <a:noAutofit/>
+          </a:bodyPr>
+          <a:lstStyle/>
+          <a:p>
+            <a:pPr algn="l">
+              <a:lnSpc>
+                <a:spcPct val="110000"/>
+              </a:lnSpc>
+            </a:pPr>
+            <a:r>
+              <a:rPr sz="950" b="1" i="0">
+                <a:solidFill>
+                  <a:srgbClr val="2B6C53"/>
+                </a:solidFill>
+                <a:latin typeface="Courier New"/>
+              </a:rPr>
+              <a:t>SERVING</a:t>
+            </a:r>
+          </a:p>
+        </p:txBody>
+      </p:sp>
       <p:pic>
         <p:nvPicPr>
-          <p:cNvPr id="13" name="Picture 12" descr="qdrant.svg.png"/>
+          <p:cNvPr id="30" name="Picture 29" descr="fastapi.svg.png"/>
           <p:cNvPicPr>
             <a:picLocks noChangeAspect="1"/>
           </p:cNvPicPr>
@@ -3546,189 +4253,17 @@
         </p:blipFill>
         <p:spPr>
           <a:xfrm>
-            <a:off x="4133087" y="1938528"/>
-            <a:ext cx="512064" cy="512064"/>
+            <a:off x="2052828" y="3995927"/>
+            <a:ext cx="603504" cy="603504"/>
           </a:xfrm>
           <a:prstGeom prst="rect">
             <a:avLst/>
           </a:prstGeom>
         </p:spPr>
       </p:pic>
-      <p:sp>
-        <p:nvSpPr>
-          <p:cNvPr id="14" name="TextBox 13"/>
-          <p:cNvSpPr txBox="1"/>
-          <p:nvPr/>
-        </p:nvSpPr>
-        <p:spPr>
-          <a:xfrm>
-            <a:off x="3703320" y="2761488"/>
-            <a:ext cx="1371600" cy="274320"/>
-          </a:xfrm>
-          <a:prstGeom prst="rect">
-            <a:avLst/>
-          </a:prstGeom>
-          <a:noFill/>
-        </p:spPr>
-        <p:txBody>
-          <a:bodyPr wrap="square" anchor="ctr" lIns="0" rIns="0" tIns="0" bIns="0">
-            <a:noAutofit/>
-          </a:bodyPr>
-          <a:lstStyle/>
-          <a:p>
-            <a:pPr algn="ctr">
-              <a:lnSpc>
-                <a:spcPct val="115000"/>
-              </a:lnSpc>
-            </a:pPr>
-            <a:r>
-              <a:rPr sz="1350" b="1">
-                <a:solidFill>
-                  <a:srgbClr val="EEF1EA"/>
-                </a:solidFill>
-                <a:latin typeface="Helvetica Neue"/>
-              </a:rPr>
-              <a:t>Qdrant</a:t>
-            </a:r>
-          </a:p>
-        </p:txBody>
-      </p:sp>
-      <p:sp>
-        <p:nvSpPr>
-          <p:cNvPr id="15" name="TextBox 14"/>
-          <p:cNvSpPr txBox="1"/>
-          <p:nvPr/>
-        </p:nvSpPr>
-        <p:spPr>
-          <a:xfrm>
-            <a:off x="3703320" y="3035808"/>
-            <a:ext cx="1371600" cy="320040"/>
-          </a:xfrm>
-          <a:prstGeom prst="rect">
-            <a:avLst/>
-          </a:prstGeom>
-          <a:noFill/>
-        </p:spPr>
-        <p:txBody>
-          <a:bodyPr wrap="square" anchor="ctr" lIns="0" rIns="0" tIns="0" bIns="0">
-            <a:noAutofit/>
-          </a:bodyPr>
-          <a:lstStyle/>
-          <a:p>
-            <a:pPr algn="ctr">
-              <a:lnSpc>
-                <a:spcPct val="115000"/>
-              </a:lnSpc>
-            </a:pPr>
-            <a:r>
-              <a:rPr sz="950" b="0">
-                <a:solidFill>
-                  <a:srgbClr val="9FA99C"/>
-                </a:solidFill>
-                <a:latin typeface="Courier New"/>
-              </a:rPr>
-              <a:t>vector store</a:t>
-            </a:r>
-          </a:p>
-        </p:txBody>
-      </p:sp>
-      <p:sp>
-        <p:nvSpPr>
-          <p:cNvPr id="16" name="Rounded Rectangle 15"/>
-          <p:cNvSpPr/>
-          <p:nvPr/>
-        </p:nvSpPr>
-        <p:spPr>
-          <a:xfrm>
-            <a:off x="5303520" y="1600200"/>
-            <a:ext cx="1600200" cy="1600200"/>
-          </a:xfrm>
-          <a:prstGeom prst="roundRect">
-            <a:avLst>
-              <a:gd name="adj" fmla="val 10000"/>
-            </a:avLst>
-          </a:prstGeom>
-          <a:solidFill>
-            <a:srgbClr val="121613"/>
-          </a:solidFill>
-          <a:ln w="12700">
-            <a:solidFill>
-              <a:srgbClr val="2B3830"/>
-            </a:solidFill>
-          </a:ln>
-          <a:effectLst/>
-        </p:spPr>
-        <p:style>
-          <a:lnRef idx="1">
-            <a:schemeClr val="accent1"/>
-          </a:lnRef>
-          <a:fillRef idx="3">
-            <a:schemeClr val="accent1"/>
-          </a:fillRef>
-          <a:effectRef idx="2">
-            <a:schemeClr val="accent1"/>
-          </a:effectRef>
-          <a:fontRef idx="minor">
-            <a:schemeClr val="lt1"/>
-          </a:fontRef>
-        </p:style>
-        <p:txBody>
-          <a:bodyPr rtlCol="0" anchor="ctr"/>
-          <a:lstStyle/>
-          <a:p>
-            <a:pPr algn="ctr"/>
-          </a:p>
-        </p:txBody>
-      </p:sp>
-      <p:sp>
-        <p:nvSpPr>
-          <p:cNvPr id="17" name="Rounded Rectangle 16"/>
-          <p:cNvSpPr/>
-          <p:nvPr/>
-        </p:nvSpPr>
-        <p:spPr>
-          <a:xfrm>
-            <a:off x="5875020" y="1755648"/>
-            <a:ext cx="457200" cy="457200"/>
-          </a:xfrm>
-          <a:prstGeom prst="roundRect">
-            <a:avLst>
-              <a:gd name="adj" fmla="val 22000"/>
-            </a:avLst>
-          </a:prstGeom>
-          <a:solidFill>
-            <a:srgbClr val="F4F6F0"/>
-          </a:solidFill>
-          <a:ln>
-            <a:noFill/>
-          </a:ln>
-          <a:effectLst/>
-        </p:spPr>
-        <p:style>
-          <a:lnRef idx="1">
-            <a:schemeClr val="accent1"/>
-          </a:lnRef>
-          <a:fillRef idx="3">
-            <a:schemeClr val="accent1"/>
-          </a:fillRef>
-          <a:effectRef idx="2">
-            <a:schemeClr val="accent1"/>
-          </a:effectRef>
-          <a:fontRef idx="minor">
-            <a:schemeClr val="lt1"/>
-          </a:fontRef>
-        </p:style>
-        <p:txBody>
-          <a:bodyPr rtlCol="0" anchor="ctr"/>
-          <a:lstStyle/>
-          <a:p>
-            <a:pPr algn="ctr"/>
-          </a:p>
-        </p:txBody>
-      </p:sp>
       <p:pic>
         <p:nvPicPr>
-          <p:cNvPr id="18" name="Picture 17" descr="huggingface.svg.png"/>
+          <p:cNvPr id="31" name="Picture 30" descr="streamlit.svg.png"/>
           <p:cNvPicPr>
             <a:picLocks noChangeAspect="1"/>
           </p:cNvPicPr>
@@ -3742,8 +4277,8 @@
         </p:blipFill>
         <p:spPr>
           <a:xfrm>
-            <a:off x="5966459" y="1847088"/>
-            <a:ext cx="274320" cy="274320"/>
+            <a:off x="3058668" y="3995927"/>
+            <a:ext cx="603504" cy="603504"/>
           </a:xfrm>
           <a:prstGeom prst="rect">
             <a:avLst/>
@@ -3752,14 +4287,14 @@
       </p:pic>
       <p:sp>
         <p:nvSpPr>
-          <p:cNvPr id="19" name="TextBox 18"/>
+          <p:cNvPr id="32" name="TextBox 31"/>
           <p:cNvSpPr txBox="1"/>
           <p:nvPr/>
         </p:nvSpPr>
         <p:spPr>
           <a:xfrm>
-            <a:off x="5394959" y="2331720"/>
-            <a:ext cx="1417320" cy="274320"/>
+            <a:off x="1874519" y="4690872"/>
+            <a:ext cx="1028700" cy="219456"/>
           </a:xfrm>
           <a:prstGeom prst="rect">
             <a:avLst/>
@@ -3774,31 +4309,31 @@
           <a:p>
             <a:pPr algn="ctr">
               <a:lnSpc>
-                <a:spcPct val="115000"/>
+                <a:spcPct val="110000"/>
               </a:lnSpc>
             </a:pPr>
             <a:r>
-              <a:rPr sz="1500" b="1">
+              <a:rPr sz="900" b="1" i="0">
                 <a:solidFill>
-                  <a:srgbClr val="EEF1EA"/>
+                  <a:srgbClr val="24272B"/>
                 </a:solidFill>
                 <a:latin typeface="Helvetica Neue"/>
               </a:rPr>
-              <a:t>Retrieval</a:t>
-            </a:r>
-          </a:p>
-        </p:txBody>
-      </p:sp>
-      <p:sp>
-        <p:nvSpPr>
-          <p:cNvPr id="20" name="TextBox 19"/>
+              <a:t>FastAPI</a:t>
+            </a:r>
+          </a:p>
+        </p:txBody>
+      </p:sp>
+      <p:sp>
+        <p:nvSpPr>
+          <p:cNvPr id="33" name="TextBox 32"/>
           <p:cNvSpPr txBox="1"/>
           <p:nvPr/>
         </p:nvSpPr>
         <p:spPr>
           <a:xfrm>
-            <a:off x="5413248" y="2660903"/>
-            <a:ext cx="1380744" cy="548640"/>
+            <a:off x="2811780" y="4690872"/>
+            <a:ext cx="1028700" cy="219456"/>
           </a:xfrm>
           <a:prstGeom prst="rect">
             <a:avLst/>
@@ -3813,44 +4348,98 @@
           <a:p>
             <a:pPr algn="ctr">
               <a:lnSpc>
-                <a:spcPct val="130000"/>
+                <a:spcPct val="110000"/>
               </a:lnSpc>
             </a:pPr>
             <a:r>
-              <a:rPr sz="950" b="0">
+              <a:rPr sz="900" b="1" i="0">
                 <a:solidFill>
-                  <a:srgbClr val="9FA99C"/>
+                  <a:srgbClr val="24272B"/>
+                </a:solidFill>
+                <a:latin typeface="Helvetica Neue"/>
+              </a:rPr>
+              <a:t>Streamlit</a:t>
+            </a:r>
+          </a:p>
+        </p:txBody>
+      </p:sp>
+      <p:sp>
+        <p:nvSpPr>
+          <p:cNvPr id="34" name="TextBox 33"/>
+          <p:cNvSpPr txBox="1"/>
+          <p:nvPr/>
+        </p:nvSpPr>
+        <p:spPr>
+          <a:xfrm>
+            <a:off x="1965960" y="4983479"/>
+            <a:ext cx="1783080" cy="457200"/>
+          </a:xfrm>
+          <a:prstGeom prst="rect">
+            <a:avLst/>
+          </a:prstGeom>
+          <a:noFill/>
+        </p:spPr>
+        <p:txBody>
+          <a:bodyPr wrap="square" anchor="ctr" lIns="0" rIns="0" tIns="0" bIns="0">
+            <a:noAutofit/>
+          </a:bodyPr>
+          <a:lstStyle/>
+          <a:p>
+            <a:pPr algn="ctr">
+              <a:lnSpc>
+                <a:spcPct val="120000"/>
+              </a:lnSpc>
+            </a:pPr>
+            <a:r>
+              <a:rPr sz="750" b="0" i="0">
+                <a:solidFill>
+                  <a:srgbClr val="6B727A"/>
                 </a:solidFill>
                 <a:latin typeface="Courier New"/>
               </a:rPr>
-              <a:t>BM25 + vector · RRF · rerank</a:t>
-            </a:r>
-          </a:p>
-        </p:txBody>
-      </p:sp>
-      <p:sp>
-        <p:nvSpPr>
-          <p:cNvPr id="21" name="Rounded Rectangle 20"/>
+              <a:t>/query · OAuth2 + JWT</a:t>
+            </a:r>
+          </a:p>
+          <a:p>
+            <a:pPr algn="ctr">
+              <a:lnSpc>
+                <a:spcPct val="120000"/>
+              </a:lnSpc>
+            </a:pPr>
+            <a:r>
+              <a:rPr sz="750" b="0" i="0">
+                <a:solidFill>
+                  <a:srgbClr val="6B727A"/>
+                </a:solidFill>
+                <a:latin typeface="Courier New"/>
+              </a:rPr>
+              <a:t>session</a:t>
+            </a:r>
+          </a:p>
+        </p:txBody>
+      </p:sp>
+      <p:sp>
+        <p:nvSpPr>
+          <p:cNvPr id="35" name="Rounded Rectangle 34"/>
           <p:cNvSpPr/>
           <p:nvPr/>
         </p:nvSpPr>
         <p:spPr>
           <a:xfrm>
-            <a:off x="7315200" y="1600200"/>
-            <a:ext cx="1600200" cy="1600200"/>
+            <a:off x="4343400" y="3246120"/>
+            <a:ext cx="3063240" cy="2331720"/>
           </a:xfrm>
           <a:prstGeom prst="roundRect">
             <a:avLst>
-              <a:gd name="adj" fmla="val 10000"/>
+              <a:gd name="adj" fmla="val 6000"/>
             </a:avLst>
           </a:prstGeom>
-          <a:solidFill>
-            <a:srgbClr val="121613"/>
-          </a:solidFill>
+          <a:noFill/>
           <a:ln w="12700">
             <a:solidFill>
-              <a:srgbClr val="2B3830"/>
+              <a:srgbClr val="444B53"/>
             </a:solidFill>
+            <a:prstDash val="sysDot"/>
           </a:ln>
           <a:effectLst/>
         </p:spPr>
@@ -3878,22 +4467,59 @@
       </p:sp>
       <p:sp>
         <p:nvSpPr>
-          <p:cNvPr id="22" name="Rounded Rectangle 21"/>
+          <p:cNvPr id="36" name="TextBox 35"/>
+          <p:cNvSpPr txBox="1"/>
+          <p:nvPr/>
+        </p:nvSpPr>
+        <p:spPr>
+          <a:xfrm>
+            <a:off x="4453128" y="3319272"/>
+            <a:ext cx="2843784" cy="201168"/>
+          </a:xfrm>
+          <a:prstGeom prst="rect">
+            <a:avLst/>
+          </a:prstGeom>
+          <a:noFill/>
+        </p:spPr>
+        <p:txBody>
+          <a:bodyPr wrap="square" anchor="ctr" lIns="0" rIns="0" tIns="0" bIns="0">
+            <a:noAutofit/>
+          </a:bodyPr>
+          <a:lstStyle/>
+          <a:p>
+            <a:pPr algn="l">
+              <a:lnSpc>
+                <a:spcPct val="110000"/>
+              </a:lnSpc>
+            </a:pPr>
+            <a:r>
+              <a:rPr sz="950" b="1" i="0">
+                <a:solidFill>
+                  <a:srgbClr val="2B6C53"/>
+                </a:solidFill>
+                <a:latin typeface="Courier New"/>
+              </a:rPr>
+              <a:t>QUERY PIPELINE</a:t>
+            </a:r>
+          </a:p>
+        </p:txBody>
+      </p:sp>
+      <p:sp>
+        <p:nvSpPr>
+          <p:cNvPr id="37" name="Oval 36"/>
           <p:cNvSpPr/>
           <p:nvPr/>
         </p:nvSpPr>
         <p:spPr>
           <a:xfrm>
-            <a:off x="7886700" y="1755648"/>
-            <a:ext cx="457200" cy="457200"/>
-          </a:xfrm>
-          <a:prstGeom prst="roundRect">
-            <a:avLst>
-              <a:gd name="adj" fmla="val 22000"/>
-            </a:avLst>
+            <a:off x="4613148" y="3758183"/>
+            <a:ext cx="512064" cy="512064"/>
+          </a:xfrm>
+          <a:prstGeom prst="ellipse">
+            <a:avLst/>
           </a:prstGeom>
           <a:solidFill>
-            <a:srgbClr val="F4F6F0"/>
+            <a:srgbClr val="EEF1F4"/>
           </a:solidFill>
           <a:ln>
             <a:noFill/>
@@ -3922,9 +4548,124 @@
           </a:p>
         </p:txBody>
       </p:sp>
+      <p:sp>
+        <p:nvSpPr>
+          <p:cNvPr id="38" name="TextBox 37"/>
+          <p:cNvSpPr txBox="1"/>
+          <p:nvPr/>
+        </p:nvSpPr>
+        <p:spPr>
+          <a:xfrm>
+            <a:off x="4613148" y="3758183"/>
+            <a:ext cx="512064" cy="512064"/>
+          </a:xfrm>
+          <a:prstGeom prst="rect">
+            <a:avLst/>
+          </a:prstGeom>
+          <a:noFill/>
+        </p:spPr>
+        <p:txBody>
+          <a:bodyPr wrap="square" anchor="ctr" lIns="0" rIns="0" tIns="0" bIns="0">
+            <a:noAutofit/>
+          </a:bodyPr>
+          <a:lstStyle/>
+          <a:p>
+            <a:pPr algn="ctr">
+              <a:lnSpc>
+                <a:spcPct val="110000"/>
+              </a:lnSpc>
+            </a:pPr>
+            <a:r>
+              <a:rPr sz="2200" b="0" i="0">
+                <a:solidFill>
+                  <a:srgbClr val="24272B"/>
+                </a:solidFill>
+                <a:latin typeface="Helvetica Neue"/>
+              </a:rPr>
+              <a:t>🔍</a:t>
+            </a:r>
+          </a:p>
+        </p:txBody>
+      </p:sp>
+      <p:sp>
+        <p:nvSpPr>
+          <p:cNvPr id="39" name="TextBox 38"/>
+          <p:cNvSpPr txBox="1"/>
+          <p:nvPr/>
+        </p:nvSpPr>
+        <p:spPr>
+          <a:xfrm>
+            <a:off x="4480560" y="4306824"/>
+            <a:ext cx="777240" cy="201168"/>
+          </a:xfrm>
+          <a:prstGeom prst="rect">
+            <a:avLst/>
+          </a:prstGeom>
+          <a:noFill/>
+        </p:spPr>
+        <p:txBody>
+          <a:bodyPr wrap="square" anchor="ctr" lIns="0" rIns="0" tIns="0" bIns="0">
+            <a:noAutofit/>
+          </a:bodyPr>
+          <a:lstStyle/>
+          <a:p>
+            <a:pPr algn="ctr">
+              <a:lnSpc>
+                <a:spcPct val="110000"/>
+              </a:lnSpc>
+            </a:pPr>
+            <a:r>
+              <a:rPr sz="850" b="1" i="0">
+                <a:solidFill>
+                  <a:srgbClr val="24272B"/>
+                </a:solidFill>
+                <a:latin typeface="Helvetica Neue"/>
+              </a:rPr>
+              <a:t>Rewrite</a:t>
+            </a:r>
+          </a:p>
+        </p:txBody>
+      </p:sp>
+      <p:cxnSp>
+        <p:nvCxnSpPr>
+          <p:cNvPr id="40" name="Connector 39"/>
+          <p:cNvCxnSpPr/>
+          <p:nvPr/>
+        </p:nvCxnSpPr>
+        <p:spPr>
+          <a:xfrm>
+            <a:off x="5143500" y="4014215"/>
+            <a:ext cx="457200" cy="0"/>
+          </a:xfrm>
+          <a:prstGeom prst="line">
+            <a:avLst/>
+          </a:prstGeom>
+          <a:ln w="12700">
+            <a:solidFill>
+              <a:srgbClr val="444B53"/>
+            </a:solidFill>
+            <a:tailEnd type="triangle" w="med" len="med"/>
+          </a:ln>
+          <a:effectLst/>
+        </p:spPr>
+        <p:style>
+          <a:lnRef idx="2">
+            <a:schemeClr val="accent1"/>
+          </a:lnRef>
+          <a:fillRef idx="0">
+            <a:schemeClr val="accent1"/>
+          </a:fillRef>
+          <a:effectRef idx="1">
+            <a:schemeClr val="accent1"/>
+          </a:effectRef>
+          <a:fontRef idx="minor">
+            <a:schemeClr val="tx1"/>
+          </a:fontRef>
+        </p:style>
+      </p:cxnSp>
       <p:pic>
         <p:nvPicPr>
-          <p:cNvPr id="23" name="Picture 22" descr="openai.svg.png"/>
+          <p:cNvPr id="41" name="Picture 40" descr="huggingface.svg.png"/>
           <p:cNvPicPr>
             <a:picLocks noChangeAspect="1"/>
           </p:cNvPicPr>
@@ -3938,8 +4679,8 @@
         </p:blipFill>
         <p:spPr>
           <a:xfrm>
-            <a:off x="7978140" y="1847088"/>
-            <a:ext cx="274320" cy="274320"/>
+            <a:off x="5618988" y="3758183"/>
+            <a:ext cx="512064" cy="512064"/>
           </a:xfrm>
           <a:prstGeom prst="rect">
             <a:avLst/>
@@ -3948,14 +4689,14 @@
       </p:pic>
       <p:sp>
         <p:nvSpPr>
-          <p:cNvPr id="24" name="TextBox 23"/>
+          <p:cNvPr id="42" name="TextBox 41"/>
           <p:cNvSpPr txBox="1"/>
           <p:nvPr/>
         </p:nvSpPr>
         <p:spPr>
           <a:xfrm>
-            <a:off x="7406640" y="2331720"/>
-            <a:ext cx="1417320" cy="274320"/>
+            <a:off x="5486400" y="4306824"/>
+            <a:ext cx="777240" cy="201168"/>
           </a:xfrm>
           <a:prstGeom prst="rect">
             <a:avLst/>
@@ -3970,125 +4711,61 @@
           <a:p>
             <a:pPr algn="ctr">
               <a:lnSpc>
-                <a:spcPct val="115000"/>
+                <a:spcPct val="110000"/>
               </a:lnSpc>
             </a:pPr>
             <a:r>
-              <a:rPr sz="1500" b="1">
+              <a:rPr sz="850" b="1" i="0">
                 <a:solidFill>
-                  <a:srgbClr val="EEF1EA"/>
+                  <a:srgbClr val="24272B"/>
                 </a:solidFill>
                 <a:latin typeface="Helvetica Neue"/>
               </a:rPr>
-              <a:t>Pipeline</a:t>
-            </a:r>
-          </a:p>
-        </p:txBody>
-      </p:sp>
-      <p:sp>
-        <p:nvSpPr>
-          <p:cNvPr id="25" name="TextBox 24"/>
-          <p:cNvSpPr txBox="1"/>
-          <p:nvPr/>
-        </p:nvSpPr>
-        <p:spPr>
-          <a:xfrm>
-            <a:off x="7424927" y="2660903"/>
-            <a:ext cx="1380744" cy="548640"/>
-          </a:xfrm>
-          <a:prstGeom prst="rect">
-            <a:avLst/>
-          </a:prstGeom>
-          <a:noFill/>
-        </p:spPr>
-        <p:txBody>
-          <a:bodyPr wrap="square" anchor="ctr" lIns="0" rIns="0" tIns="0" bIns="0">
-            <a:noAutofit/>
-          </a:bodyPr>
-          <a:lstStyle/>
-          <a:p>
-            <a:pPr algn="ctr">
-              <a:lnSpc>
-                <a:spcPct val="130000"/>
-              </a:lnSpc>
-            </a:pPr>
-            <a:r>
-              <a:rPr sz="950" b="0">
-                <a:solidFill>
-                  <a:srgbClr val="9FA99C"/>
-                </a:solidFill>
-                <a:latin typeface="Courier New"/>
-              </a:rPr>
-              <a:t>HyDE rewrite ·</a:t>
-            </a:r>
-          </a:p>
-          <a:p>
-            <a:pPr algn="ctr">
-              <a:lnSpc>
-                <a:spcPct val="130000"/>
-              </a:lnSpc>
-            </a:pPr>
-            <a:r>
-              <a:rPr sz="950" b="0">
-                <a:solidFill>
-                  <a:srgbClr val="9FA99C"/>
-                </a:solidFill>
-                <a:latin typeface="Courier New"/>
-              </a:rPr>
-              <a:t>GPT-4o generate</a:t>
-            </a:r>
-          </a:p>
-        </p:txBody>
-      </p:sp>
-      <p:sp>
-        <p:nvSpPr>
-          <p:cNvPr id="26" name="Rounded Rectangle 25"/>
-          <p:cNvSpPr/>
-          <p:nvPr/>
-        </p:nvSpPr>
-        <p:spPr>
-          <a:xfrm>
-            <a:off x="9372600" y="1737360"/>
-            <a:ext cx="914400" cy="914400"/>
-          </a:xfrm>
-          <a:prstGeom prst="roundRect">
-            <a:avLst>
-              <a:gd name="adj" fmla="val 22000"/>
-            </a:avLst>
-          </a:prstGeom>
-          <a:solidFill>
-            <a:srgbClr val="F4F6F0"/>
-          </a:solidFill>
-          <a:ln>
-            <a:noFill/>
+              <a:t>Rerank</a:t>
+            </a:r>
+          </a:p>
+        </p:txBody>
+      </p:sp>
+      <p:cxnSp>
+        <p:nvCxnSpPr>
+          <p:cNvPr id="43" name="Connector 42"/>
+          <p:cNvCxnSpPr/>
+          <p:nvPr/>
+        </p:nvCxnSpPr>
+        <p:spPr>
+          <a:xfrm>
+            <a:off x="6149340" y="4014215"/>
+            <a:ext cx="457200" cy="0"/>
+          </a:xfrm>
+          <a:prstGeom prst="line">
+            <a:avLst/>
+          </a:prstGeom>
+          <a:ln w="12700">
+            <a:solidFill>
+              <a:srgbClr val="444B53"/>
+            </a:solidFill>
+            <a:tailEnd type="triangle" w="med" len="med"/>
           </a:ln>
           <a:effectLst/>
         </p:spPr>
         <p:style>
-          <a:lnRef idx="1">
+          <a:lnRef idx="2">
             <a:schemeClr val="accent1"/>
           </a:lnRef>
-          <a:fillRef idx="3">
+          <a:fillRef idx="0">
             <a:schemeClr val="accent1"/>
           </a:fillRef>
-          <a:effectRef idx="2">
+          <a:effectRef idx="1">
             <a:schemeClr val="accent1"/>
           </a:effectRef>
           <a:fontRef idx="minor">
-            <a:schemeClr val="lt1"/>
+            <a:schemeClr val="tx1"/>
           </a:fontRef>
         </p:style>
-        <p:txBody>
-          <a:bodyPr rtlCol="0" anchor="ctr"/>
-          <a:lstStyle/>
-          <a:p>
-            <a:pPr algn="ctr"/>
-          </a:p>
-        </p:txBody>
-      </p:sp>
+      </p:cxnSp>
       <p:pic>
         <p:nvPicPr>
-          <p:cNvPr id="27" name="Picture 26" descr="fastapi.svg.png"/>
+          <p:cNvPr id="44" name="Picture 43" descr="openai.svg.png"/>
           <p:cNvPicPr>
             <a:picLocks noChangeAspect="1"/>
           </p:cNvPicPr>
@@ -4102,7 +4779,7 @@
         </p:blipFill>
         <p:spPr>
           <a:xfrm>
-            <a:off x="9573768" y="1938528"/>
+            <a:off x="6624828" y="3758183"/>
             <a:ext cx="512064" cy="512064"/>
           </a:xfrm>
           <a:prstGeom prst="rect">
@@ -4112,14 +4789,14 @@
       </p:pic>
       <p:sp>
         <p:nvSpPr>
-          <p:cNvPr id="28" name="TextBox 27"/>
+          <p:cNvPr id="45" name="TextBox 44"/>
           <p:cNvSpPr txBox="1"/>
           <p:nvPr/>
         </p:nvSpPr>
         <p:spPr>
           <a:xfrm>
-            <a:off x="9144000" y="2761488"/>
-            <a:ext cx="1371600" cy="274320"/>
+            <a:off x="6492240" y="4306824"/>
+            <a:ext cx="777240" cy="201168"/>
           </a:xfrm>
           <a:prstGeom prst="rect">
             <a:avLst/>
@@ -4134,31 +4811,31 @@
           <a:p>
             <a:pPr algn="ctr">
               <a:lnSpc>
-                <a:spcPct val="115000"/>
+                <a:spcPct val="110000"/>
               </a:lnSpc>
             </a:pPr>
             <a:r>
-              <a:rPr sz="1350" b="1">
+              <a:rPr sz="850" b="1" i="0">
                 <a:solidFill>
-                  <a:srgbClr val="EEF1EA"/>
+                  <a:srgbClr val="24272B"/>
                 </a:solidFill>
                 <a:latin typeface="Helvetica Neue"/>
               </a:rPr>
-              <a:t>FastAPI</a:t>
-            </a:r>
-          </a:p>
-        </p:txBody>
-      </p:sp>
-      <p:sp>
-        <p:nvSpPr>
-          <p:cNvPr id="29" name="TextBox 28"/>
+              <a:t>Generate</a:t>
+            </a:r>
+          </a:p>
+        </p:txBody>
+      </p:sp>
+      <p:sp>
+        <p:nvSpPr>
+          <p:cNvPr id="46" name="TextBox 45"/>
           <p:cNvSpPr txBox="1"/>
           <p:nvPr/>
         </p:nvSpPr>
         <p:spPr>
           <a:xfrm>
-            <a:off x="9144000" y="3035808"/>
-            <a:ext cx="1371600" cy="320040"/>
+            <a:off x="4434840" y="4800600"/>
+            <a:ext cx="2880360" cy="640080"/>
           </a:xfrm>
           <a:prstGeom prst="rect">
             <a:avLst/>
@@ -4173,42 +4850,59 @@
           <a:p>
             <a:pPr algn="ctr">
               <a:lnSpc>
-                <a:spcPct val="115000"/>
+                <a:spcPct val="125000"/>
               </a:lnSpc>
             </a:pPr>
             <a:r>
-              <a:rPr sz="950" b="0">
+              <a:rPr sz="750" b="0" i="0">
                 <a:solidFill>
-                  <a:srgbClr val="9FA99C"/>
+                  <a:srgbClr val="6B727A"/>
                 </a:solidFill>
                 <a:latin typeface="Courier New"/>
               </a:rPr>
-              <a:t>/query</a:t>
-            </a:r>
-          </a:p>
-        </p:txBody>
-      </p:sp>
-      <p:sp>
-        <p:nvSpPr>
-          <p:cNvPr id="30" name="Rounded Rectangle 29"/>
+              <a:t>HyDE · hybrid search (BM25 + vector, RRF)</a:t>
+            </a:r>
+          </a:p>
+          <a:p>
+            <a:pPr algn="ctr">
+              <a:lnSpc>
+                <a:spcPct val="125000"/>
+              </a:lnSpc>
+            </a:pPr>
+            <a:r>
+              <a:rPr sz="750" b="0" i="0">
+                <a:solidFill>
+                  <a:srgbClr val="6B727A"/>
+                </a:solidFill>
+                <a:latin typeface="Courier New"/>
+              </a:rPr>
+              <a:t>cross-encoder rerank · GPT-4o + citations</a:t>
+            </a:r>
+          </a:p>
+        </p:txBody>
+      </p:sp>
+      <p:sp>
+        <p:nvSpPr>
+          <p:cNvPr id="47" name="Rounded Rectangle 46"/>
           <p:cNvSpPr/>
           <p:nvPr/>
         </p:nvSpPr>
         <p:spPr>
           <a:xfrm>
-            <a:off x="10789920" y="1737360"/>
-            <a:ext cx="914400" cy="914400"/>
+            <a:off x="7909560" y="3246120"/>
+            <a:ext cx="1874519" cy="2331720"/>
           </a:xfrm>
           <a:prstGeom prst="roundRect">
             <a:avLst>
-              <a:gd name="adj" fmla="val 22000"/>
+              <a:gd name="adj" fmla="val 6000"/>
             </a:avLst>
           </a:prstGeom>
-          <a:solidFill>
-            <a:srgbClr val="F4F6F0"/>
-          </a:solidFill>
-          <a:ln>
-            <a:noFill/>
+          <a:noFill/>
+          <a:ln w="12700">
+            <a:solidFill>
+              <a:srgbClr val="444B53"/>
+            </a:solidFill>
+            <a:prstDash val="sysDot"/>
           </a:ln>
           <a:effectLst/>
         </p:spPr>
@@ -4234,9 +4928,48 @@
           </a:p>
         </p:txBody>
       </p:sp>
+      <p:sp>
+        <p:nvSpPr>
+          <p:cNvPr id="48" name="TextBox 47"/>
+          <p:cNvSpPr txBox="1"/>
+          <p:nvPr/>
+        </p:nvSpPr>
+        <p:spPr>
+          <a:xfrm>
+            <a:off x="8019288" y="3319272"/>
+            <a:ext cx="1655063" cy="201168"/>
+          </a:xfrm>
+          <a:prstGeom prst="rect">
+            <a:avLst/>
+          </a:prstGeom>
+          <a:noFill/>
+        </p:spPr>
+        <p:txBody>
+          <a:bodyPr wrap="square" anchor="ctr" lIns="0" rIns="0" tIns="0" bIns="0">
+            <a:noAutofit/>
+          </a:bodyPr>
+          <a:lstStyle/>
+          <a:p>
+            <a:pPr algn="l">
+              <a:lnSpc>
+                <a:spcPct val="110000"/>
+              </a:lnSpc>
+            </a:pPr>
+            <a:r>
+              <a:rPr sz="950" b="1" i="0">
+                <a:solidFill>
+                  <a:srgbClr val="2B6C53"/>
+                </a:solidFill>
+                <a:latin typeface="Courier New"/>
+              </a:rPr>
+              <a:t>STORAGE</a:t>
+            </a:r>
+          </a:p>
+        </p:txBody>
+      </p:sp>
       <p:pic>
         <p:nvPicPr>
-          <p:cNvPr id="31" name="Picture 30" descr="streamlit.svg.png"/>
+          <p:cNvPr id="49" name="Picture 48" descr="qdrant.svg.png"/>
           <p:cNvPicPr>
             <a:picLocks noChangeAspect="1"/>
           </p:cNvPicPr>
@@ -4250,8 +4983,8 @@
         </p:blipFill>
         <p:spPr>
           <a:xfrm>
-            <a:off x="10991088" y="1938528"/>
-            <a:ext cx="512064" cy="512064"/>
+            <a:off x="8517636" y="3922776"/>
+            <a:ext cx="658368" cy="658368"/>
           </a:xfrm>
           <a:prstGeom prst="rect">
             <a:avLst/>
@@ -4260,14 +4993,14 @@
       </p:pic>
       <p:sp>
         <p:nvSpPr>
-          <p:cNvPr id="32" name="TextBox 31"/>
+          <p:cNvPr id="50" name="TextBox 49"/>
           <p:cNvSpPr txBox="1"/>
           <p:nvPr/>
         </p:nvSpPr>
         <p:spPr>
           <a:xfrm>
-            <a:off x="10561320" y="2761488"/>
-            <a:ext cx="1371600" cy="274320"/>
+            <a:off x="7909560" y="4672583"/>
+            <a:ext cx="1874519" cy="219456"/>
           </a:xfrm>
           <a:prstGeom prst="rect">
             <a:avLst/>
@@ -4282,31 +5015,31 @@
           <a:p>
             <a:pPr algn="ctr">
               <a:lnSpc>
-                <a:spcPct val="115000"/>
+                <a:spcPct val="110000"/>
               </a:lnSpc>
             </a:pPr>
             <a:r>
-              <a:rPr sz="1350" b="1">
+              <a:rPr sz="1000" b="1" i="0">
                 <a:solidFill>
-                  <a:srgbClr val="EEF1EA"/>
+                  <a:srgbClr val="24272B"/>
                 </a:solidFill>
                 <a:latin typeface="Helvetica Neue"/>
               </a:rPr>
-              <a:t>Streamlit</a:t>
-            </a:r>
-          </a:p>
-        </p:txBody>
-      </p:sp>
-      <p:sp>
-        <p:nvSpPr>
-          <p:cNvPr id="33" name="TextBox 32"/>
+              <a:t>Qdrant</a:t>
+            </a:r>
+          </a:p>
+        </p:txBody>
+      </p:sp>
+      <p:sp>
+        <p:nvSpPr>
+          <p:cNvPr id="51" name="TextBox 50"/>
           <p:cNvSpPr txBox="1"/>
           <p:nvPr/>
         </p:nvSpPr>
         <p:spPr>
           <a:xfrm>
-            <a:off x="10561320" y="3035808"/>
-            <a:ext cx="1371600" cy="320040"/>
+            <a:off x="8001000" y="4965192"/>
+            <a:ext cx="1691639" cy="457200"/>
           </a:xfrm>
           <a:prstGeom prst="rect">
             <a:avLst/>
@@ -4321,41 +5054,322 @@
           <a:p>
             <a:pPr algn="ctr">
               <a:lnSpc>
-                <a:spcPct val="115000"/>
+                <a:spcPct val="120000"/>
               </a:lnSpc>
             </a:pPr>
             <a:r>
-              <a:rPr sz="950" b="0">
+              <a:rPr sz="750" b="0" i="0">
                 <a:solidFill>
-                  <a:srgbClr val="9FA99C"/>
+                  <a:srgbClr val="6B727A"/>
                 </a:solidFill>
                 <a:latin typeface="Courier New"/>
               </a:rPr>
-              <a:t>chat UI</a:t>
+              <a:t>vector store</a:t>
+            </a:r>
+          </a:p>
+          <a:p>
+            <a:pPr algn="ctr">
+              <a:lnSpc>
+                <a:spcPct val="120000"/>
+              </a:lnSpc>
+            </a:pPr>
+            <a:r>
+              <a:rPr sz="750" b="0" i="0">
+                <a:solidFill>
+                  <a:srgbClr val="6B727A"/>
+                </a:solidFill>
+                <a:latin typeface="Courier New"/>
+              </a:rPr>
+              <a:t>+ in-memory BM25 index</a:t>
+            </a:r>
+          </a:p>
+        </p:txBody>
+      </p:sp>
+      <p:sp>
+        <p:nvSpPr>
+          <p:cNvPr id="52" name="Rounded Rectangle 51"/>
+          <p:cNvSpPr/>
+          <p:nvPr/>
+        </p:nvSpPr>
+        <p:spPr>
+          <a:xfrm>
+            <a:off x="10195560" y="3246120"/>
+            <a:ext cx="1325880" cy="2331720"/>
+          </a:xfrm>
+          <a:prstGeom prst="roundRect">
+            <a:avLst>
+              <a:gd name="adj" fmla="val 6000"/>
+            </a:avLst>
+          </a:prstGeom>
+          <a:noFill/>
+          <a:ln w="12700">
+            <a:solidFill>
+              <a:srgbClr val="444B53"/>
+            </a:solidFill>
+            <a:prstDash val="sysDot"/>
+          </a:ln>
+          <a:effectLst/>
+        </p:spPr>
+        <p:style>
+          <a:lnRef idx="1">
+            <a:schemeClr val="accent1"/>
+          </a:lnRef>
+          <a:fillRef idx="3">
+            <a:schemeClr val="accent1"/>
+          </a:fillRef>
+          <a:effectRef idx="2">
+            <a:schemeClr val="accent1"/>
+          </a:effectRef>
+          <a:fontRef idx="minor">
+            <a:schemeClr val="lt1"/>
+          </a:fontRef>
+        </p:style>
+        <p:txBody>
+          <a:bodyPr rtlCol="0" anchor="ctr"/>
+          <a:lstStyle/>
+          <a:p>
+            <a:pPr algn="ctr"/>
+          </a:p>
+        </p:txBody>
+      </p:sp>
+      <p:sp>
+        <p:nvSpPr>
+          <p:cNvPr id="53" name="TextBox 52"/>
+          <p:cNvSpPr txBox="1"/>
+          <p:nvPr/>
+        </p:nvSpPr>
+        <p:spPr>
+          <a:xfrm>
+            <a:off x="10287000" y="3319272"/>
+            <a:ext cx="1143000" cy="201168"/>
+          </a:xfrm>
+          <a:prstGeom prst="rect">
+            <a:avLst/>
+          </a:prstGeom>
+          <a:noFill/>
+        </p:spPr>
+        <p:txBody>
+          <a:bodyPr wrap="square" anchor="ctr" lIns="0" rIns="0" tIns="0" bIns="0">
+            <a:noAutofit/>
+          </a:bodyPr>
+          <a:lstStyle/>
+          <a:p>
+            <a:pPr algn="l">
+              <a:lnSpc>
+                <a:spcPct val="110000"/>
+              </a:lnSpc>
+            </a:pPr>
+            <a:r>
+              <a:rPr sz="950" b="1" i="0">
+                <a:solidFill>
+                  <a:srgbClr val="2B6C53"/>
+                </a:solidFill>
+                <a:latin typeface="Courier New"/>
+              </a:rPr>
+              <a:t>TRACING</a:t>
+            </a:r>
+          </a:p>
+        </p:txBody>
+      </p:sp>
+      <p:sp>
+        <p:nvSpPr>
+          <p:cNvPr id="54" name="Oval 53"/>
+          <p:cNvSpPr/>
+          <p:nvPr/>
+        </p:nvSpPr>
+        <p:spPr>
+          <a:xfrm>
+            <a:off x="10602468" y="3950207"/>
+            <a:ext cx="512064" cy="512064"/>
+          </a:xfrm>
+          <a:prstGeom prst="ellipse">
+            <a:avLst/>
+          </a:prstGeom>
+          <a:solidFill>
+            <a:srgbClr val="1C241F"/>
+          </a:solidFill>
+          <a:ln>
+            <a:noFill/>
+          </a:ln>
+          <a:effectLst/>
+        </p:spPr>
+        <p:style>
+          <a:lnRef idx="1">
+            <a:schemeClr val="accent1"/>
+          </a:lnRef>
+          <a:fillRef idx="3">
+            <a:schemeClr val="accent1"/>
+          </a:fillRef>
+          <a:effectRef idx="2">
+            <a:schemeClr val="accent1"/>
+          </a:effectRef>
+          <a:fontRef idx="minor">
+            <a:schemeClr val="lt1"/>
+          </a:fontRef>
+        </p:style>
+        <p:txBody>
+          <a:bodyPr rtlCol="0" anchor="ctr"/>
+          <a:lstStyle/>
+          <a:p>
+            <a:pPr algn="ctr"/>
+          </a:p>
+        </p:txBody>
+      </p:sp>
+      <p:sp>
+        <p:nvSpPr>
+          <p:cNvPr id="55" name="TextBox 54"/>
+          <p:cNvSpPr txBox="1"/>
+          <p:nvPr/>
+        </p:nvSpPr>
+        <p:spPr>
+          <a:xfrm>
+            <a:off x="10602468" y="3950207"/>
+            <a:ext cx="512064" cy="512064"/>
+          </a:xfrm>
+          <a:prstGeom prst="rect">
+            <a:avLst/>
+          </a:prstGeom>
+          <a:noFill/>
+        </p:spPr>
+        <p:txBody>
+          <a:bodyPr wrap="square" anchor="ctr" lIns="0" rIns="0" tIns="0" bIns="0">
+            <a:noAutofit/>
+          </a:bodyPr>
+          <a:lstStyle/>
+          <a:p>
+            <a:pPr algn="ctr">
+              <a:lnSpc>
+                <a:spcPct val="110000"/>
+              </a:lnSpc>
+            </a:pPr>
+            <a:r>
+              <a:rPr sz="2000" b="1" i="0">
+                <a:solidFill>
+                  <a:srgbClr val="6FE3A6"/>
+                </a:solidFill>
+                <a:latin typeface="Courier New"/>
+              </a:rPr>
+              <a:t>L</a:t>
+            </a:r>
+          </a:p>
+        </p:txBody>
+      </p:sp>
+      <p:sp>
+        <p:nvSpPr>
+          <p:cNvPr id="56" name="TextBox 55"/>
+          <p:cNvSpPr txBox="1"/>
+          <p:nvPr/>
+        </p:nvSpPr>
+        <p:spPr>
+          <a:xfrm>
+            <a:off x="10195560" y="4544568"/>
+            <a:ext cx="1325880" cy="201168"/>
+          </a:xfrm>
+          <a:prstGeom prst="rect">
+            <a:avLst/>
+          </a:prstGeom>
+          <a:noFill/>
+        </p:spPr>
+        <p:txBody>
+          <a:bodyPr wrap="square" anchor="ctr" lIns="0" rIns="0" tIns="0" bIns="0">
+            <a:noAutofit/>
+          </a:bodyPr>
+          <a:lstStyle/>
+          <a:p>
+            <a:pPr algn="ctr">
+              <a:lnSpc>
+                <a:spcPct val="110000"/>
+              </a:lnSpc>
+            </a:pPr>
+            <a:r>
+              <a:rPr sz="950" b="1" i="0">
+                <a:solidFill>
+                  <a:srgbClr val="24272B"/>
+                </a:solidFill>
+                <a:latin typeface="Helvetica Neue"/>
+              </a:rPr>
+              <a:t>Langfuse</a:t>
+            </a:r>
+          </a:p>
+        </p:txBody>
+      </p:sp>
+      <p:sp>
+        <p:nvSpPr>
+          <p:cNvPr id="57" name="TextBox 56"/>
+          <p:cNvSpPr txBox="1"/>
+          <p:nvPr/>
+        </p:nvSpPr>
+        <p:spPr>
+          <a:xfrm>
+            <a:off x="10241280" y="4782312"/>
+            <a:ext cx="1234439" cy="548640"/>
+          </a:xfrm>
+          <a:prstGeom prst="rect">
+            <a:avLst/>
+          </a:prstGeom>
+          <a:noFill/>
+        </p:spPr>
+        <p:txBody>
+          <a:bodyPr wrap="square" anchor="ctr" lIns="0" rIns="0" tIns="0" bIns="0">
+            <a:noAutofit/>
+          </a:bodyPr>
+          <a:lstStyle/>
+          <a:p>
+            <a:pPr algn="ctr">
+              <a:lnSpc>
+                <a:spcPct val="120000"/>
+              </a:lnSpc>
+            </a:pPr>
+            <a:r>
+              <a:rPr sz="750" b="0" i="0">
+                <a:solidFill>
+                  <a:srgbClr val="6B727A"/>
+                </a:solidFill>
+                <a:latin typeface="Courier New"/>
+              </a:rPr>
+              <a:t>every stage is a</a:t>
+            </a:r>
+          </a:p>
+          <a:p>
+            <a:pPr algn="ctr">
+              <a:lnSpc>
+                <a:spcPct val="120000"/>
+              </a:lnSpc>
+            </a:pPr>
+            <a:r>
+              <a:rPr sz="750" b="0" i="0">
+                <a:solidFill>
+                  <a:srgbClr val="6B727A"/>
+                </a:solidFill>
+                <a:latin typeface="Courier New"/>
+              </a:rPr>
+              <a:t>traced span</a:t>
             </a:r>
           </a:p>
         </p:txBody>
       </p:sp>
       <p:cxnSp>
         <p:nvCxnSpPr>
-          <p:cNvPr id="34" name="Connector 33"/>
+          <p:cNvPr id="58" name="Connector 57"/>
           <p:cNvCxnSpPr/>
           <p:nvPr/>
         </p:nvCxnSpPr>
         <p:spPr>
-          <a:xfrm>
-            <a:off x="1463040" y="2194560"/>
-            <a:ext cx="411479" cy="0"/>
+          <a:xfrm flipV="1">
+            <a:off x="1060704" y="4251960"/>
+            <a:ext cx="813815" cy="457200"/>
           </a:xfrm>
           <a:prstGeom prst="line">
             <a:avLst/>
           </a:prstGeom>
-          <a:ln w="25400">
+          <a:ln w="19050">
             <a:solidFill>
-              <a:srgbClr val="6FE3A6"/>
+              <a:srgbClr val="1A1D21"/>
             </a:solidFill>
             <a:tailEnd type="triangle" w="med" len="med"/>
+            <a:headEnd type="triangle" w="med" len="med"/>
           </a:ln>
+          <a:effectLst/>
         </p:spPr>
         <p:style>
           <a:lnRef idx="2">
@@ -4374,24 +5388,26 @@
       </p:cxnSp>
       <p:cxnSp>
         <p:nvCxnSpPr>
-          <p:cNvPr id="35" name="Connector 34"/>
+          <p:cNvPr id="59" name="Connector 58"/>
           <p:cNvCxnSpPr/>
           <p:nvPr/>
         </p:nvCxnSpPr>
         <p:spPr>
           <a:xfrm>
-            <a:off x="3474720" y="2194560"/>
-            <a:ext cx="411480" cy="0"/>
+            <a:off x="3840479" y="4251960"/>
+            <a:ext cx="502921" cy="0"/>
           </a:xfrm>
           <a:prstGeom prst="line">
             <a:avLst/>
           </a:prstGeom>
-          <a:ln w="25400">
+          <a:ln w="19050">
             <a:solidFill>
-              <a:srgbClr val="6FE3A6"/>
+              <a:srgbClr val="1A1D21"/>
             </a:solidFill>
             <a:tailEnd type="triangle" w="med" len="med"/>
+            <a:headEnd type="triangle" w="med" len="med"/>
           </a:ln>
+          <a:effectLst/>
         </p:spPr>
         <p:style>
           <a:lnRef idx="2">
@@ -4410,24 +5426,179 @@
       </p:cxnSp>
       <p:cxnSp>
         <p:nvCxnSpPr>
-          <p:cNvPr id="36" name="Connector 35"/>
+          <p:cNvPr id="60" name="Connector 59"/>
           <p:cNvCxnSpPr/>
           <p:nvPr/>
         </p:nvCxnSpPr>
         <p:spPr>
           <a:xfrm>
-            <a:off x="4892040" y="2194560"/>
-            <a:ext cx="411480" cy="0"/>
+            <a:off x="7406640" y="4251960"/>
+            <a:ext cx="502920" cy="0"/>
           </a:xfrm>
           <a:prstGeom prst="line">
             <a:avLst/>
           </a:prstGeom>
-          <a:ln w="25400">
+          <a:ln w="19050">
             <a:solidFill>
-              <a:srgbClr val="6FE3A6"/>
+              <a:srgbClr val="1A1D21"/>
+            </a:solidFill>
+            <a:tailEnd type="triangle" w="med" len="med"/>
+            <a:headEnd type="triangle" w="med" len="med"/>
+          </a:ln>
+          <a:effectLst/>
+        </p:spPr>
+        <p:style>
+          <a:lnRef idx="2">
+            <a:schemeClr val="accent1"/>
+          </a:lnRef>
+          <a:fillRef idx="0">
+            <a:schemeClr val="accent1"/>
+          </a:fillRef>
+          <a:effectRef idx="1">
+            <a:schemeClr val="accent1"/>
+          </a:effectRef>
+          <a:fontRef idx="minor">
+            <a:schemeClr val="tx1"/>
+          </a:fontRef>
+        </p:style>
+      </p:cxnSp>
+      <p:sp>
+        <p:nvSpPr>
+          <p:cNvPr id="61" name="TextBox 60"/>
+          <p:cNvSpPr txBox="1"/>
+          <p:nvPr/>
+        </p:nvSpPr>
+        <p:spPr>
+          <a:xfrm>
+            <a:off x="7452360" y="4288536"/>
+            <a:ext cx="411480" cy="274320"/>
+          </a:xfrm>
+          <a:prstGeom prst="rect">
+            <a:avLst/>
+          </a:prstGeom>
+          <a:noFill/>
+        </p:spPr>
+        <p:txBody>
+          <a:bodyPr wrap="square" anchor="ctr" lIns="0" rIns="0" tIns="0" bIns="0">
+            <a:noAutofit/>
+          </a:bodyPr>
+          <a:lstStyle/>
+          <a:p>
+            <a:pPr algn="ctr">
+              <a:lnSpc>
+                <a:spcPct val="110000"/>
+              </a:lnSpc>
+            </a:pPr>
+            <a:r>
+              <a:rPr sz="700" b="0" i="1">
+                <a:solidFill>
+                  <a:srgbClr val="6B727A"/>
+                </a:solidFill>
+                <a:latin typeface="Helvetica Neue"/>
+              </a:rPr>
+              <a:t>top-20 → top-5</a:t>
+            </a:r>
+          </a:p>
+        </p:txBody>
+      </p:sp>
+      <p:cxnSp>
+        <p:nvCxnSpPr>
+          <p:cNvPr id="62" name="Connector 61"/>
+          <p:cNvCxnSpPr/>
+          <p:nvPr/>
+        </p:nvCxnSpPr>
+        <p:spPr>
+          <a:xfrm>
+            <a:off x="5783579" y="2514600"/>
+            <a:ext cx="3063241" cy="731520"/>
+          </a:xfrm>
+          <a:prstGeom prst="bentConnector3">
+            <a:avLst/>
+          </a:prstGeom>
+          <a:ln w="19050">
+            <a:solidFill>
+              <a:srgbClr val="1A1D21"/>
             </a:solidFill>
             <a:tailEnd type="triangle" w="med" len="med"/>
           </a:ln>
+          <a:effectLst/>
+        </p:spPr>
+        <p:style>
+          <a:lnRef idx="2">
+            <a:schemeClr val="accent1"/>
+          </a:lnRef>
+          <a:fillRef idx="0">
+            <a:schemeClr val="accent1"/>
+          </a:fillRef>
+          <a:effectRef idx="1">
+            <a:schemeClr val="accent1"/>
+          </a:effectRef>
+          <a:fontRef idx="minor">
+            <a:schemeClr val="tx1"/>
+          </a:fontRef>
+        </p:style>
+      </p:cxnSp>
+      <p:sp>
+        <p:nvSpPr>
+          <p:cNvPr id="63" name="TextBox 62"/>
+          <p:cNvSpPr txBox="1"/>
+          <p:nvPr/>
+        </p:nvSpPr>
+        <p:spPr>
+          <a:xfrm>
+            <a:off x="8069580" y="2569464"/>
+            <a:ext cx="1554480" cy="201168"/>
+          </a:xfrm>
+          <a:prstGeom prst="rect">
+            <a:avLst/>
+          </a:prstGeom>
+          <a:noFill/>
+        </p:spPr>
+        <p:txBody>
+          <a:bodyPr wrap="square" anchor="ctr" lIns="0" rIns="0" tIns="0" bIns="0">
+            <a:noAutofit/>
+          </a:bodyPr>
+          <a:lstStyle/>
+          <a:p>
+            <a:pPr algn="ctr">
+              <a:lnSpc>
+                <a:spcPct val="110000"/>
+              </a:lnSpc>
+            </a:pPr>
+            <a:r>
+              <a:rPr sz="700" b="0" i="1">
+                <a:solidFill>
+                  <a:srgbClr val="6B727A"/>
+                </a:solidFill>
+                <a:latin typeface="Helvetica Neue"/>
+              </a:rPr>
+              <a:t>idempotent upsert</a:t>
+            </a:r>
+          </a:p>
+        </p:txBody>
+      </p:sp>
+      <p:cxnSp>
+        <p:nvCxnSpPr>
+          <p:cNvPr id="64" name="Connector 63"/>
+          <p:cNvCxnSpPr/>
+          <p:nvPr/>
+        </p:nvCxnSpPr>
+        <p:spPr>
+          <a:xfrm flipV="1">
+            <a:off x="2857500" y="2926079"/>
+            <a:ext cx="0" cy="320041"/>
+          </a:xfrm>
+          <a:prstGeom prst="bentConnector3">
+            <a:avLst/>
+          </a:prstGeom>
+          <a:ln w="13970">
+            <a:solidFill>
+              <a:srgbClr val="9AA3AC"/>
+            </a:solidFill>
+            <a:prstDash val="dash"/>
+            <a:tailEnd type="triangle" w="med" len="med"/>
+          </a:ln>
+          <a:effectLst/>
         </p:spPr>
         <p:style>
           <a:lnRef idx="2">
@@ -4446,24 +5617,26 @@
       </p:cxnSp>
       <p:cxnSp>
         <p:nvCxnSpPr>
-          <p:cNvPr id="37" name="Connector 36"/>
+          <p:cNvPr id="65" name="Connector 64"/>
           <p:cNvCxnSpPr/>
           <p:nvPr/>
         </p:nvCxnSpPr>
         <p:spPr>
           <a:xfrm>
-            <a:off x="6903720" y="2194560"/>
-            <a:ext cx="411480" cy="0"/>
-          </a:xfrm>
-          <a:prstGeom prst="line">
-            <a:avLst/>
-          </a:prstGeom>
-          <a:ln w="25400">
+            <a:off x="2857500" y="2926079"/>
+            <a:ext cx="7086600" cy="0"/>
+          </a:xfrm>
+          <a:prstGeom prst="bentConnector3">
+            <a:avLst/>
+          </a:prstGeom>
+          <a:ln w="13970">
             <a:solidFill>
-              <a:srgbClr val="6FE3A6"/>
+              <a:srgbClr val="9AA3AC"/>
             </a:solidFill>
+            <a:prstDash val="dash"/>
             <a:tailEnd type="triangle" w="med" len="med"/>
           </a:ln>
+          <a:effectLst/>
         </p:spPr>
         <p:style>
           <a:lnRef idx="2">
@@ -4482,24 +5655,26 @@
       </p:cxnSp>
       <p:cxnSp>
         <p:nvCxnSpPr>
-          <p:cNvPr id="38" name="Connector 37"/>
+          <p:cNvPr id="66" name="Connector 65"/>
           <p:cNvCxnSpPr/>
           <p:nvPr/>
         </p:nvCxnSpPr>
         <p:spPr>
           <a:xfrm>
-            <a:off x="8915400" y="2194560"/>
-            <a:ext cx="411480" cy="0"/>
+            <a:off x="9944100" y="2926079"/>
+            <a:ext cx="914400" cy="320041"/>
           </a:xfrm>
           <a:prstGeom prst="line">
             <a:avLst/>
           </a:prstGeom>
-          <a:ln w="25400">
+          <a:ln w="13970">
             <a:solidFill>
-              <a:srgbClr val="6FE3A6"/>
+              <a:srgbClr val="9AA3AC"/>
             </a:solidFill>
+            <a:prstDash val="dash"/>
             <a:tailEnd type="triangle" w="med" len="med"/>
           </a:ln>
+          <a:effectLst/>
         </p:spPr>
         <p:style>
           <a:lnRef idx="2">
@@ -4518,24 +5693,26 @@
       </p:cxnSp>
       <p:cxnSp>
         <p:nvCxnSpPr>
-          <p:cNvPr id="39" name="Connector 38"/>
+          <p:cNvPr id="67" name="Connector 66"/>
           <p:cNvCxnSpPr/>
           <p:nvPr/>
         </p:nvCxnSpPr>
         <p:spPr>
-          <a:xfrm>
-            <a:off x="10332719" y="2194560"/>
-            <a:ext cx="411481" cy="0"/>
-          </a:xfrm>
-          <a:prstGeom prst="line">
-            <a:avLst/>
-          </a:prstGeom>
-          <a:ln w="25400">
+          <a:xfrm flipV="1">
+            <a:off x="5875020" y="3063239"/>
+            <a:ext cx="0" cy="182881"/>
+          </a:xfrm>
+          <a:prstGeom prst="bentConnector3">
+            <a:avLst/>
+          </a:prstGeom>
+          <a:ln w="13970">
             <a:solidFill>
-              <a:srgbClr val="6FE3A6"/>
+              <a:srgbClr val="9AA3AC"/>
             </a:solidFill>
+            <a:prstDash val="dash"/>
             <a:tailEnd type="triangle" w="med" len="med"/>
           </a:ln>
+          <a:effectLst/>
         </p:spPr>
         <p:style>
           <a:lnRef idx="2">
@@ -4554,25 +5731,26 @@
       </p:cxnSp>
       <p:cxnSp>
         <p:nvCxnSpPr>
-          <p:cNvPr id="40" name="Connector 39"/>
+          <p:cNvPr id="68" name="Connector 67"/>
           <p:cNvCxnSpPr/>
           <p:nvPr/>
         </p:nvCxnSpPr>
         <p:spPr>
           <a:xfrm>
-            <a:off x="8115300" y="3200400"/>
-            <a:ext cx="0" cy="411480"/>
-          </a:xfrm>
-          <a:prstGeom prst="line">
-            <a:avLst/>
-          </a:prstGeom>
-          <a:ln w="25400">
+            <a:off x="5875020" y="3063239"/>
+            <a:ext cx="4983480" cy="0"/>
+          </a:xfrm>
+          <a:prstGeom prst="bentConnector3">
+            <a:avLst/>
+          </a:prstGeom>
+          <a:ln w="13970">
             <a:solidFill>
-              <a:srgbClr val="4A5C52"/>
+              <a:srgbClr val="9AA3AC"/>
             </a:solidFill>
             <a:prstDash val="dash"/>
             <a:tailEnd type="triangle" w="med" len="med"/>
           </a:ln>
+          <a:effectLst/>
         </p:spPr>
         <p:style>
           <a:lnRef idx="2">
@@ -4591,26 +5769,63 @@
       </p:cxnSp>
       <p:sp>
         <p:nvSpPr>
-          <p:cNvPr id="41" name="Rounded Rectangle 40"/>
+          <p:cNvPr id="69" name="TextBox 68"/>
+          <p:cNvSpPr txBox="1"/>
+          <p:nvPr/>
+        </p:nvSpPr>
+        <p:spPr>
+          <a:xfrm>
+            <a:off x="2948940" y="2642615"/>
+            <a:ext cx="3840480" cy="219456"/>
+          </a:xfrm>
+          <a:prstGeom prst="rect">
+            <a:avLst/>
+          </a:prstGeom>
+          <a:noFill/>
+        </p:spPr>
+        <p:txBody>
+          <a:bodyPr wrap="square" anchor="ctr" lIns="0" rIns="0" tIns="0" bIns="0">
+            <a:noAutofit/>
+          </a:bodyPr>
+          <a:lstStyle/>
+          <a:p>
+            <a:pPr algn="ctr">
+              <a:lnSpc>
+                <a:spcPct val="110000"/>
+              </a:lnSpc>
+            </a:pPr>
+            <a:r>
+              <a:rPr sz="750" b="0" i="1">
+                <a:solidFill>
+                  <a:srgbClr val="6B727A"/>
+                </a:solidFill>
+                <a:latin typeface="Helvetica Neue"/>
+              </a:rPr>
+              <a:t>trace spans (per pipeline stage)</a:t>
+            </a:r>
+          </a:p>
+        </p:txBody>
+      </p:sp>
+      <p:sp>
+        <p:nvSpPr>
+          <p:cNvPr id="70" name="Hexagon 69"/>
           <p:cNvSpPr/>
           <p:nvPr/>
         </p:nvSpPr>
         <p:spPr>
           <a:xfrm>
-            <a:off x="7246620" y="3611880"/>
-            <a:ext cx="1737360" cy="566928"/>
-          </a:xfrm>
-          <a:prstGeom prst="roundRect">
-            <a:avLst>
-              <a:gd name="adj" fmla="val 50000"/>
-            </a:avLst>
+            <a:off x="11457432" y="5696712"/>
+            <a:ext cx="402336" cy="402336"/>
+          </a:xfrm>
+          <a:prstGeom prst="hexagon">
+            <a:avLst/>
           </a:prstGeom>
           <a:solidFill>
-            <a:srgbClr val="121613"/>
+            <a:srgbClr val="EEF1F4"/>
           </a:solidFill>
-          <a:ln w="12700">
+          <a:ln w="9525">
             <a:solidFill>
-              <a:srgbClr val="2B3830"/>
+              <a:srgbClr val="444B53"/>
             </a:solidFill>
           </a:ln>
           <a:effectLst/>
@@ -4639,22 +5854,61 @@
       </p:sp>
       <p:sp>
         <p:nvSpPr>
-          <p:cNvPr id="42" name="Rounded Rectangle 41"/>
+          <p:cNvPr id="71" name="TextBox 70"/>
+          <p:cNvSpPr txBox="1"/>
+          <p:nvPr/>
+        </p:nvSpPr>
+        <p:spPr>
+          <a:xfrm>
+            <a:off x="10104120" y="6117336"/>
+            <a:ext cx="1737360" cy="201168"/>
+          </a:xfrm>
+          <a:prstGeom prst="rect">
+            <a:avLst/>
+          </a:prstGeom>
+          <a:noFill/>
+        </p:spPr>
+        <p:txBody>
+          <a:bodyPr wrap="square" anchor="ctr" lIns="0" rIns="0" tIns="0" bIns="0">
+            <a:noAutofit/>
+          </a:bodyPr>
+          <a:lstStyle/>
+          <a:p>
+            <a:pPr algn="r">
+              <a:lnSpc>
+                <a:spcPct val="110000"/>
+              </a:lnSpc>
+            </a:pPr>
+            <a:r>
+              <a:rPr sz="750" b="0" i="0">
+                <a:solidFill>
+                  <a:srgbClr val="6B727A"/>
+                </a:solidFill>
+                <a:latin typeface="Courier New"/>
+              </a:rPr>
+              <a:t>docker network: rag_internal</a:t>
+            </a:r>
+          </a:p>
+        </p:txBody>
+      </p:sp>
+      <p:sp>
+        <p:nvSpPr>
+          <p:cNvPr id="72" name="Rounded Rectangle 71"/>
           <p:cNvSpPr/>
           <p:nvPr/>
         </p:nvSpPr>
         <p:spPr>
           <a:xfrm>
-            <a:off x="7374636" y="3739896"/>
-            <a:ext cx="310896" cy="310896"/>
+            <a:off x="365760" y="6263640"/>
+            <a:ext cx="292608" cy="292608"/>
           </a:xfrm>
           <a:prstGeom prst="roundRect">
             <a:avLst>
-              <a:gd name="adj" fmla="val 30000"/>
+              <a:gd name="adj" fmla="val 25000"/>
             </a:avLst>
           </a:prstGeom>
           <a:solidFill>
-            <a:srgbClr val="1C241F"/>
+            <a:srgbClr val="2B6C53"/>
           </a:solidFill>
           <a:ln>
             <a:noFill/>
@@ -4685,14 +5939,14 @@
       </p:sp>
       <p:sp>
         <p:nvSpPr>
-          <p:cNvPr id="43" name="TextBox 42"/>
+          <p:cNvPr id="73" name="TextBox 72"/>
           <p:cNvSpPr txBox="1"/>
           <p:nvPr/>
         </p:nvSpPr>
         <p:spPr>
           <a:xfrm>
-            <a:off x="7374636" y="3739896"/>
-            <a:ext cx="310896" cy="310896"/>
+            <a:off x="365760" y="6263640"/>
+            <a:ext cx="292608" cy="292608"/>
           </a:xfrm>
           <a:prstGeom prst="rect">
             <a:avLst/>
@@ -4707,31 +5961,31 @@
           <a:p>
             <a:pPr algn="ctr">
               <a:lnSpc>
-                <a:spcPct val="115000"/>
+                <a:spcPct val="110000"/>
               </a:lnSpc>
             </a:pPr>
             <a:r>
-              <a:rPr sz="1400" b="1">
+              <a:rPr sz="1500" b="1" i="0">
                 <a:solidFill>
-                  <a:srgbClr val="6FE3A6"/>
+                  <a:srgbClr val="FFFFFF"/>
                 </a:solidFill>
-                <a:latin typeface="Courier New"/>
+                <a:latin typeface="Helvetica Neue"/>
               </a:rPr>
-              <a:t>L</a:t>
-            </a:r>
-          </a:p>
-        </p:txBody>
-      </p:sp>
-      <p:sp>
-        <p:nvSpPr>
-          <p:cNvPr id="44" name="TextBox 43"/>
+              <a:t>P</a:t>
+            </a:r>
+          </a:p>
+        </p:txBody>
+      </p:sp>
+      <p:sp>
+        <p:nvSpPr>
+          <p:cNvPr id="74" name="TextBox 73"/>
           <p:cNvSpPr txBox="1"/>
           <p:nvPr/>
         </p:nvSpPr>
         <p:spPr>
           <a:xfrm>
-            <a:off x="7776971" y="3685032"/>
-            <a:ext cx="1115567" cy="219456"/>
+            <a:off x="749808" y="6245352"/>
+            <a:ext cx="2743200" cy="329184"/>
           </a:xfrm>
           <a:prstGeom prst="rect">
             <a:avLst/>
@@ -4744,97 +5998,19 @@
           </a:bodyPr>
           <a:lstStyle/>
           <a:p>
-            <a:pPr algn="l">
+            <a:pPr algn="ctr">
               <a:lnSpc>
-                <a:spcPct val="115000"/>
+                <a:spcPct val="110000"/>
               </a:lnSpc>
             </a:pPr>
             <a:r>
-              <a:rPr sz="1250" b="1">
+              <a:rPr sz="1300" b="1" i="0">
                 <a:solidFill>
-                  <a:srgbClr val="EEF1EA"/>
+                  <a:srgbClr val="24272B"/>
                 </a:solidFill>
                 <a:latin typeface="Helvetica Neue"/>
               </a:rPr>
-              <a:t>Langfuse</a:t>
-            </a:r>
-          </a:p>
-        </p:txBody>
-      </p:sp>
-      <p:sp>
-        <p:nvSpPr>
-          <p:cNvPr id="45" name="TextBox 44"/>
-          <p:cNvSpPr txBox="1"/>
-          <p:nvPr/>
-        </p:nvSpPr>
-        <p:spPr>
-          <a:xfrm>
-            <a:off x="7776971" y="3904488"/>
-            <a:ext cx="1115567" cy="219456"/>
-          </a:xfrm>
-          <a:prstGeom prst="rect">
-            <a:avLst/>
-          </a:prstGeom>
-          <a:noFill/>
-        </p:spPr>
-        <p:txBody>
-          <a:bodyPr wrap="square" anchor="ctr" lIns="0" rIns="0" tIns="0" bIns="0">
-            <a:noAutofit/>
-          </a:bodyPr>
-          <a:lstStyle/>
-          <a:p>
-            <a:pPr algn="l">
-              <a:lnSpc>
-                <a:spcPct val="115000"/>
-              </a:lnSpc>
-            </a:pPr>
-            <a:r>
-              <a:rPr sz="850" b="0">
-                <a:solidFill>
-                  <a:srgbClr val="9FA99C"/>
-                </a:solidFill>
-                <a:latin typeface="Courier New"/>
-              </a:rPr>
-              <a:t>every span traced</a:t>
-            </a:r>
-          </a:p>
-        </p:txBody>
-      </p:sp>
-      <p:sp>
-        <p:nvSpPr>
-          <p:cNvPr id="46" name="TextBox 45"/>
-          <p:cNvSpPr txBox="1"/>
-          <p:nvPr/>
-        </p:nvSpPr>
-        <p:spPr>
-          <a:xfrm>
-            <a:off x="457200" y="6263640"/>
-            <a:ext cx="11277295" cy="365760"/>
-          </a:xfrm>
-          <a:prstGeom prst="rect">
-            <a:avLst/>
-          </a:prstGeom>
-          <a:noFill/>
-        </p:spPr>
-        <p:txBody>
-          <a:bodyPr wrap="square" anchor="ctr" lIns="0" rIns="0" tIns="0" bIns="0">
-            <a:noAutofit/>
-          </a:bodyPr>
-          <a:lstStyle/>
-          <a:p>
-            <a:pPr algn="ctr">
-              <a:lnSpc>
-                <a:spcPct val="115000"/>
-              </a:lnSpc>
-            </a:pPr>
-            <a:r>
-              <a:rPr sz="1100" b="0">
-                <a:solidFill>
-                  <a:srgbClr val="9FA99C"/>
-                </a:solidFill>
-                <a:latin typeface="Helvetica Neue"/>
-              </a:rPr>
-              <a:t>ERPNext  →  Ingestion  →  Qdrant  →  Retrieval  →  Pipeline  →  FastAPI  →  Streamlit — every stage of a query is a traced span in Langfuse.</a:t>
+              <a:t>procurement-rag</a:t>
             </a:r>
           </a:p>
         </p:txBody>

</xml_diff>